<commit_message>
Add Nielsen competitive, pack-size & state readout (national Urban, May'26)
Sourced from an unmerged prior branch (claude/retail-channel-performance-hz0q8h)
that had richer Nielsen slides (competitor brand rankings, Mamaearth pack-size
mix, zone/state share) than the MT-vs-GT panel used so far. Adds it as a THIRD
independent dataset across all three deliverables:

- dashboard: new NIELSEN_COMP object + nielsenCompHtml() card on Market Share
  tab, clearly labeled as national-Urban/no-channel-split/May'26 vintage,
  never merged with D or RETAIL_AUDIT
- Excel: new "Nielsen Competitor & State" sheet + one extra action-tracker row
- PPT: two new slides (Competitive Landscape, Pack-Size & State White Space)

Key derived insight: Uttar Pradesh and Maharashtra are the largest
under-penetrated states across both Facewash and Shampoo.

Co-Authored-By: Claude Sonnet 5 <noreply@anthropic.com>
Claude-Session: https://claude.ai/code/session_01GvaoD8EEUD7VSbiFjT5PH1
</commit_message>
<xml_diff>
--- a/reports/MT_vs_GT_Deep_Dive.pptx
+++ b/reports/MT_vs_GT_Deep_Dive.pptx
@@ -11,6 +11,8 @@
     <p:sldId id="259" r:id="rIdSlide4"/>
     <p:sldId id="260" r:id="rIdSlide5"/>
     <p:sldId id="261" r:id="rIdSlide6"/>
+    <p:sldId id="262" r:id="rIdSlide7"/>
+    <p:sldId id="263" r:id="rIdSlide8"/>
   </p:sldIdLst>
   <p:sldSz cx="12191695" cy="6858000" type="screen16x9"/>
   <p:notesSz cx="6858000" cy="12191695"/>
@@ -3588,6 +3590,3142 @@
         </p:nvSpPr>
         <p:spPr>
           <a:xfrm>
+            <a:off x="548640" y="320040"/>
+            <a:ext cx="10972800" cy="548640"/>
+          </a:xfrm>
+          <a:prstGeom prst="rect">
+            <a:avLst/>
+          </a:prstGeom>
+          <a:noFill/>
+        </p:spPr>
+        <p:txBody>
+          <a:bodyPr wrap="square" anchor="t" lIns="0" tIns="0" rIns="0" bIns="0">
+            <a:noAutofit/>
+          </a:bodyPr>
+          <a:lstStyle/>
+          <a:p>
+            <a:pPr algn="l"/>
+            <a:r>
+              <a:rPr lang="en-US" sz="2600" b="1" dirty="0">
+                <a:solidFill>
+                  <a:srgbClr val="1A1A1A"/>
+                </a:solidFill>
+                <a:latin typeface="Cambria"/>
+              </a:rPr>
+              <a:t>Competitive Landscape — National Urban (Nielsen)</a:t>
+            </a:r>
+          </a:p>
+        </p:txBody>
+      </p:sp>
+      <p:sp>
+        <p:nvSpPr>
+          <p:cNvPr id="3" name="TextBox 3"/>
+          <p:cNvSpPr txBox="1"/>
+          <p:nvPr/>
+        </p:nvSpPr>
+        <p:spPr>
+          <a:xfrm>
+            <a:off x="548640" y="804672"/>
+            <a:ext cx="10972800" cy="411480"/>
+          </a:xfrm>
+          <a:prstGeom prst="rect">
+            <a:avLst/>
+          </a:prstGeom>
+          <a:noFill/>
+        </p:spPr>
+        <p:txBody>
+          <a:bodyPr wrap="square" anchor="t" lIns="0" tIns="0" rIns="0" bIns="0">
+            <a:noAutofit/>
+          </a:bodyPr>
+          <a:lstStyle/>
+          <a:p>
+            <a:pPr algn="l"/>
+            <a:r>
+              <a:rPr lang="en-US" sz="1200" i="1" dirty="0">
+                <a:solidFill>
+                  <a:srgbClr val="666666"/>
+                </a:solidFill>
+                <a:latin typeface="Calibri"/>
+              </a:rPr>
+              <a:t>Separate data source: total Urban MS Val vs named competitors, May'26 vintage (not the MT/GT panel in prior slides).</a:t>
+            </a:r>
+          </a:p>
+        </p:txBody>
+      </p:sp>
+      <p:sp>
+        <p:nvSpPr>
+          <p:cNvPr id="4" name="TextBox 4"/>
+          <p:cNvSpPr txBox="1"/>
+          <p:nvPr/>
+        </p:nvSpPr>
+        <p:spPr>
+          <a:xfrm>
+            <a:off x="548640" y="1325880"/>
+            <a:ext cx="5440680" cy="320040"/>
+          </a:xfrm>
+          <a:prstGeom prst="rect">
+            <a:avLst/>
+          </a:prstGeom>
+          <a:noFill/>
+        </p:spPr>
+        <p:txBody>
+          <a:bodyPr wrap="square" anchor="t" lIns="0" tIns="0" rIns="0" bIns="0">
+            <a:noAutofit/>
+          </a:bodyPr>
+          <a:lstStyle/>
+          <a:p>
+            <a:pPr algn="l"/>
+            <a:r>
+              <a:rPr lang="en-US" sz="1400" b="1" dirty="0">
+                <a:solidFill>
+                  <a:srgbClr val="6D2E46"/>
+                </a:solidFill>
+                <a:latin typeface="Calibri"/>
+              </a:rPr>
+              <a:t>Facewash — top competitors</a:t>
+            </a:r>
+          </a:p>
+        </p:txBody>
+      </p:sp>
+      <p:graphicFrame>
+        <p:nvGraphicFramePr>
+          <p:cNvPr id="5" name="Table 5"/>
+          <p:cNvGraphicFramePr>
+            <a:graphicFrameLocks noGrp="1"/>
+          </p:cNvGraphicFramePr>
+          <p:nvPr/>
+        </p:nvGraphicFramePr>
+        <p:xfrm>
+          <a:off x="548640" y="1691640"/>
+          <a:ext cx="5440680" cy="2880360"/>
+        </p:xfrm>
+        <a:graphic>
+          <a:graphicData uri="http://schemas.openxmlformats.org/drawingml/2006/table">
+            <a:tbl>
+              <a:tblPr firstRow="1" bandRow="0">
+                <a:tableStyleId>{5C22544A-7EE6-4342-B048-85BDC9FD1C3A}</a:tableStyleId>
+              </a:tblPr>
+              <a:tblGrid>
+                <a:gridCol w="731520"/>
+                <a:gridCol w="2011680"/>
+                <a:gridCol w="1188720"/>
+                <a:gridCol w="960120"/>
+                <a:gridCol w="548640"/>
+              </a:tblGrid>
+              <a:tr h="411480">
+                <a:tc>
+                  <a:txBody>
+                    <a:bodyPr/>
+                    <a:lstStyle/>
+                    <a:p>
+                      <a:pPr algn="l"/>
+                      <a:r>
+                        <a:rPr lang="en-US" sz="1100" b="1" dirty="0">
+                          <a:solidFill>
+                            <a:srgbClr val="FFFFFF"/>
+                          </a:solidFill>
+                          <a:latin typeface="Calibri"/>
+                        </a:rPr>
+                        <a:t>Rank</a:t>
+                      </a:r>
+                    </a:p>
+                  </a:txBody>
+                  <a:tcPr marL="45720" marR="45720" marT="22860" marB="22860" anchor="ctr">
+                    <a:solidFill>
+                      <a:srgbClr val="2F3C7E"/>
+                    </a:solidFill>
+                  </a:tcPr>
+                </a:tc>
+                <a:tc>
+                  <a:txBody>
+                    <a:bodyPr/>
+                    <a:lstStyle/>
+                    <a:p>
+                      <a:pPr algn="l"/>
+                      <a:r>
+                        <a:rPr lang="en-US" sz="1100" b="1" dirty="0">
+                          <a:solidFill>
+                            <a:srgbClr val="FFFFFF"/>
+                          </a:solidFill>
+                          <a:latin typeface="Calibri"/>
+                        </a:rPr>
+                        <a:t>Brand</a:t>
+                      </a:r>
+                    </a:p>
+                  </a:txBody>
+                  <a:tcPr marL="45720" marR="45720" marT="22860" marB="22860" anchor="ctr">
+                    <a:solidFill>
+                      <a:srgbClr val="2F3C7E"/>
+                    </a:solidFill>
+                  </a:tcPr>
+                </a:tc>
+                <a:tc>
+                  <a:txBody>
+                    <a:bodyPr/>
+                    <a:lstStyle/>
+                    <a:p>
+                      <a:pPr algn="l"/>
+                      <a:r>
+                        <a:rPr lang="en-US" sz="1100" b="1" dirty="0">
+                          <a:solidFill>
+                            <a:srgbClr val="FFFFFF"/>
+                          </a:solidFill>
+                          <a:latin typeface="Calibri"/>
+                        </a:rPr>
+                        <a:t>Value (Cr)</a:t>
+                      </a:r>
+                    </a:p>
+                  </a:txBody>
+                  <a:tcPr marL="45720" marR="45720" marT="22860" marB="22860" anchor="ctr">
+                    <a:solidFill>
+                      <a:srgbClr val="2F3C7E"/>
+                    </a:solidFill>
+                  </a:tcPr>
+                </a:tc>
+                <a:tc>
+                  <a:txBody>
+                    <a:bodyPr/>
+                    <a:lstStyle/>
+                    <a:p>
+                      <a:pPr algn="l"/>
+                      <a:r>
+                        <a:rPr lang="en-US" sz="1100" b="1" dirty="0">
+                          <a:solidFill>
+                            <a:srgbClr val="FFFFFF"/>
+                          </a:solidFill>
+                          <a:latin typeface="Calibri"/>
+                        </a:rPr>
+                        <a:t>MS Val %</a:t>
+                      </a:r>
+                    </a:p>
+                  </a:txBody>
+                  <a:tcPr marL="45720" marR="45720" marT="22860" marB="22860" anchor="ctr">
+                    <a:solidFill>
+                      <a:srgbClr val="2F3C7E"/>
+                    </a:solidFill>
+                  </a:tcPr>
+                </a:tc>
+                <a:tc>
+                  <a:txBody>
+                    <a:bodyPr/>
+                    <a:lstStyle/>
+                    <a:p>
+                      <a:pPr algn="l"/>
+                      <a:r>
+                        <a:rPr lang="en-US" sz="1100" b="1" dirty="0">
+                          <a:solidFill>
+                            <a:srgbClr val="FFFFFF"/>
+                          </a:solidFill>
+                          <a:latin typeface="Calibri"/>
+                        </a:rPr>
+                        <a:t>YoY (bps)</a:t>
+                      </a:r>
+                    </a:p>
+                  </a:txBody>
+                  <a:tcPr marL="45720" marR="45720" marT="22860" marB="22860" anchor="ctr">
+                    <a:solidFill>
+                      <a:srgbClr val="2F3C7E"/>
+                    </a:solidFill>
+                  </a:tcPr>
+                </a:tc>
+              </a:tr>
+              <a:tr h="411480">
+                <a:tc>
+                  <a:txBody>
+                    <a:bodyPr/>
+                    <a:lstStyle/>
+                    <a:p>
+                      <a:pPr algn="l"/>
+                      <a:r>
+                        <a:rPr lang="en-US" sz="1100" dirty="0">
+                          <a:solidFill>
+                            <a:srgbClr val="1A1A1A"/>
+                          </a:solidFill>
+                          <a:latin typeface="Calibri"/>
+                        </a:rPr>
+                        <a:t>1</a:t>
+                      </a:r>
+                    </a:p>
+                  </a:txBody>
+                  <a:tcPr marL="45720" marR="45720" marT="22860" marB="22860" anchor="ctr">
+                    <a:solidFill>
+                      <a:srgbClr val="FFFFFF"/>
+                    </a:solidFill>
+                  </a:tcPr>
+                </a:tc>
+                <a:tc>
+                  <a:txBody>
+                    <a:bodyPr/>
+                    <a:lstStyle/>
+                    <a:p>
+                      <a:pPr algn="l"/>
+                      <a:r>
+                        <a:rPr lang="en-US" sz="1100" dirty="0">
+                          <a:solidFill>
+                            <a:srgbClr val="1A1A1A"/>
+                          </a:solidFill>
+                          <a:latin typeface="Calibri"/>
+                        </a:rPr>
+                        <a:t>Himalaya</a:t>
+                      </a:r>
+                    </a:p>
+                  </a:txBody>
+                  <a:tcPr marL="45720" marR="45720" marT="22860" marB="22860" anchor="ctr">
+                    <a:solidFill>
+                      <a:srgbClr val="FFFFFF"/>
+                    </a:solidFill>
+                  </a:tcPr>
+                </a:tc>
+                <a:tc>
+                  <a:txBody>
+                    <a:bodyPr/>
+                    <a:lstStyle/>
+                    <a:p>
+                      <a:pPr algn="l"/>
+                      <a:r>
+                        <a:rPr lang="en-US" sz="1100" dirty="0">
+                          <a:solidFill>
+                            <a:srgbClr val="1A1A1A"/>
+                          </a:solidFill>
+                          <a:latin typeface="Calibri"/>
+                        </a:rPr>
+                        <a:t>17.9</a:t>
+                      </a:r>
+                    </a:p>
+                  </a:txBody>
+                  <a:tcPr marL="45720" marR="45720" marT="22860" marB="22860" anchor="ctr">
+                    <a:solidFill>
+                      <a:srgbClr val="FFFFFF"/>
+                    </a:solidFill>
+                  </a:tcPr>
+                </a:tc>
+                <a:tc>
+                  <a:txBody>
+                    <a:bodyPr/>
+                    <a:lstStyle/>
+                    <a:p>
+                      <a:pPr algn="l"/>
+                      <a:r>
+                        <a:rPr lang="en-US" sz="1100" dirty="0">
+                          <a:solidFill>
+                            <a:srgbClr val="1A1A1A"/>
+                          </a:solidFill>
+                          <a:latin typeface="Calibri"/>
+                        </a:rPr>
+                        <a:t>22%</a:t>
+                      </a:r>
+                    </a:p>
+                  </a:txBody>
+                  <a:tcPr marL="45720" marR="45720" marT="22860" marB="22860" anchor="ctr">
+                    <a:solidFill>
+                      <a:srgbClr val="FFFFFF"/>
+                    </a:solidFill>
+                  </a:tcPr>
+                </a:tc>
+                <a:tc>
+                  <a:txBody>
+                    <a:bodyPr/>
+                    <a:lstStyle/>
+                    <a:p>
+                      <a:pPr algn="l"/>
+                      <a:r>
+                        <a:rPr lang="en-US" sz="1100" dirty="0">
+                          <a:solidFill>
+                            <a:srgbClr val="1A1A1A"/>
+                          </a:solidFill>
+                          <a:latin typeface="Calibri"/>
+                        </a:rPr>
+                        <a:t>-328</a:t>
+                      </a:r>
+                    </a:p>
+                  </a:txBody>
+                  <a:tcPr marL="45720" marR="45720" marT="22860" marB="22860" anchor="ctr">
+                    <a:solidFill>
+                      <a:srgbClr val="FFFFFF"/>
+                    </a:solidFill>
+                  </a:tcPr>
+                </a:tc>
+              </a:tr>
+              <a:tr h="411480">
+                <a:tc>
+                  <a:txBody>
+                    <a:bodyPr/>
+                    <a:lstStyle/>
+                    <a:p>
+                      <a:pPr algn="l"/>
+                      <a:r>
+                        <a:rPr lang="en-US" sz="1100" dirty="0">
+                          <a:solidFill>
+                            <a:srgbClr val="1A1A1A"/>
+                          </a:solidFill>
+                          <a:latin typeface="Calibri"/>
+                        </a:rPr>
+                        <a:t>2</a:t>
+                      </a:r>
+                    </a:p>
+                  </a:txBody>
+                  <a:tcPr marL="45720" marR="45720" marT="22860" marB="22860" anchor="ctr">
+                    <a:solidFill>
+                      <a:srgbClr val="FFFFFF"/>
+                    </a:solidFill>
+                  </a:tcPr>
+                </a:tc>
+                <a:tc>
+                  <a:txBody>
+                    <a:bodyPr/>
+                    <a:lstStyle/>
+                    <a:p>
+                      <a:pPr algn="l"/>
+                      <a:r>
+                        <a:rPr lang="en-US" sz="1100" dirty="0">
+                          <a:solidFill>
+                            <a:srgbClr val="1A1A1A"/>
+                          </a:solidFill>
+                          <a:latin typeface="Calibri"/>
+                        </a:rPr>
+                        <a:t>Garnier</a:t>
+                      </a:r>
+                    </a:p>
+                  </a:txBody>
+                  <a:tcPr marL="45720" marR="45720" marT="22860" marB="22860" anchor="ctr">
+                    <a:solidFill>
+                      <a:srgbClr val="FFFFFF"/>
+                    </a:solidFill>
+                  </a:tcPr>
+                </a:tc>
+                <a:tc>
+                  <a:txBody>
+                    <a:bodyPr/>
+                    <a:lstStyle/>
+                    <a:p>
+                      <a:pPr algn="l"/>
+                      <a:r>
+                        <a:rPr lang="en-US" sz="1100" dirty="0">
+                          <a:solidFill>
+                            <a:srgbClr val="1A1A1A"/>
+                          </a:solidFill>
+                          <a:latin typeface="Calibri"/>
+                        </a:rPr>
+                        <a:t>11.8</a:t>
+                      </a:r>
+                    </a:p>
+                  </a:txBody>
+                  <a:tcPr marL="45720" marR="45720" marT="22860" marB="22860" anchor="ctr">
+                    <a:solidFill>
+                      <a:srgbClr val="FFFFFF"/>
+                    </a:solidFill>
+                  </a:tcPr>
+                </a:tc>
+                <a:tc>
+                  <a:txBody>
+                    <a:bodyPr/>
+                    <a:lstStyle/>
+                    <a:p>
+                      <a:pPr algn="l"/>
+                      <a:r>
+                        <a:rPr lang="en-US" sz="1100" dirty="0">
+                          <a:solidFill>
+                            <a:srgbClr val="1A1A1A"/>
+                          </a:solidFill>
+                          <a:latin typeface="Calibri"/>
+                        </a:rPr>
+                        <a:t>14%</a:t>
+                      </a:r>
+                    </a:p>
+                  </a:txBody>
+                  <a:tcPr marL="45720" marR="45720" marT="22860" marB="22860" anchor="ctr">
+                    <a:solidFill>
+                      <a:srgbClr val="FFFFFF"/>
+                    </a:solidFill>
+                  </a:tcPr>
+                </a:tc>
+                <a:tc>
+                  <a:txBody>
+                    <a:bodyPr/>
+                    <a:lstStyle/>
+                    <a:p>
+                      <a:pPr algn="l"/>
+                      <a:r>
+                        <a:rPr lang="en-US" sz="1100" dirty="0">
+                          <a:solidFill>
+                            <a:srgbClr val="1A1A1A"/>
+                          </a:solidFill>
+                          <a:latin typeface="Calibri"/>
+                        </a:rPr>
+                        <a:t>+55</a:t>
+                      </a:r>
+                    </a:p>
+                  </a:txBody>
+                  <a:tcPr marL="45720" marR="45720" marT="22860" marB="22860" anchor="ctr">
+                    <a:solidFill>
+                      <a:srgbClr val="FFFFFF"/>
+                    </a:solidFill>
+                  </a:tcPr>
+                </a:tc>
+              </a:tr>
+              <a:tr h="411480">
+                <a:tc>
+                  <a:txBody>
+                    <a:bodyPr/>
+                    <a:lstStyle/>
+                    <a:p>
+                      <a:pPr algn="l"/>
+                      <a:r>
+                        <a:rPr lang="en-US" sz="1100" dirty="0">
+                          <a:solidFill>
+                            <a:srgbClr val="1A1A1A"/>
+                          </a:solidFill>
+                          <a:latin typeface="Calibri"/>
+                        </a:rPr>
+                        <a:t>3</a:t>
+                      </a:r>
+                    </a:p>
+                  </a:txBody>
+                  <a:tcPr marL="45720" marR="45720" marT="22860" marB="22860" anchor="ctr">
+                    <a:solidFill>
+                      <a:srgbClr val="FFFFFF"/>
+                    </a:solidFill>
+                  </a:tcPr>
+                </a:tc>
+                <a:tc>
+                  <a:txBody>
+                    <a:bodyPr/>
+                    <a:lstStyle/>
+                    <a:p>
+                      <a:pPr algn="l"/>
+                      <a:r>
+                        <a:rPr lang="en-US" sz="1100" dirty="0">
+                          <a:solidFill>
+                            <a:srgbClr val="1A1A1A"/>
+                          </a:solidFill>
+                          <a:latin typeface="Calibri"/>
+                        </a:rPr>
+                        <a:t>Pond's</a:t>
+                      </a:r>
+                    </a:p>
+                  </a:txBody>
+                  <a:tcPr marL="45720" marR="45720" marT="22860" marB="22860" anchor="ctr">
+                    <a:solidFill>
+                      <a:srgbClr val="FFFFFF"/>
+                    </a:solidFill>
+                  </a:tcPr>
+                </a:tc>
+                <a:tc>
+                  <a:txBody>
+                    <a:bodyPr/>
+                    <a:lstStyle/>
+                    <a:p>
+                      <a:pPr algn="l"/>
+                      <a:r>
+                        <a:rPr lang="en-US" sz="1100" dirty="0">
+                          <a:solidFill>
+                            <a:srgbClr val="1A1A1A"/>
+                          </a:solidFill>
+                          <a:latin typeface="Calibri"/>
+                        </a:rPr>
+                        <a:t>11.4</a:t>
+                      </a:r>
+                    </a:p>
+                  </a:txBody>
+                  <a:tcPr marL="45720" marR="45720" marT="22860" marB="22860" anchor="ctr">
+                    <a:solidFill>
+                      <a:srgbClr val="FFFFFF"/>
+                    </a:solidFill>
+                  </a:tcPr>
+                </a:tc>
+                <a:tc>
+                  <a:txBody>
+                    <a:bodyPr/>
+                    <a:lstStyle/>
+                    <a:p>
+                      <a:pPr algn="l"/>
+                      <a:r>
+                        <a:rPr lang="en-US" sz="1100" dirty="0">
+                          <a:solidFill>
+                            <a:srgbClr val="1A1A1A"/>
+                          </a:solidFill>
+                          <a:latin typeface="Calibri"/>
+                        </a:rPr>
+                        <a:t>14%</a:t>
+                      </a:r>
+                    </a:p>
+                  </a:txBody>
+                  <a:tcPr marL="45720" marR="45720" marT="22860" marB="22860" anchor="ctr">
+                    <a:solidFill>
+                      <a:srgbClr val="FFFFFF"/>
+                    </a:solidFill>
+                  </a:tcPr>
+                </a:tc>
+                <a:tc>
+                  <a:txBody>
+                    <a:bodyPr/>
+                    <a:lstStyle/>
+                    <a:p>
+                      <a:pPr algn="l"/>
+                      <a:r>
+                        <a:rPr lang="en-US" sz="1100" dirty="0">
+                          <a:solidFill>
+                            <a:srgbClr val="1A1A1A"/>
+                          </a:solidFill>
+                          <a:latin typeface="Calibri"/>
+                        </a:rPr>
+                        <a:t>-61</a:t>
+                      </a:r>
+                    </a:p>
+                  </a:txBody>
+                  <a:tcPr marL="45720" marR="45720" marT="22860" marB="22860" anchor="ctr">
+                    <a:solidFill>
+                      <a:srgbClr val="FFFFFF"/>
+                    </a:solidFill>
+                  </a:tcPr>
+                </a:tc>
+              </a:tr>
+              <a:tr h="411480">
+                <a:tc>
+                  <a:txBody>
+                    <a:bodyPr/>
+                    <a:lstStyle/>
+                    <a:p>
+                      <a:pPr algn="l"/>
+                      <a:r>
+                        <a:rPr lang="en-US" sz="1100" dirty="0">
+                          <a:solidFill>
+                            <a:srgbClr val="1A1A1A"/>
+                          </a:solidFill>
+                          <a:latin typeface="Calibri"/>
+                        </a:rPr>
+                        <a:t>4</a:t>
+                      </a:r>
+                    </a:p>
+                  </a:txBody>
+                  <a:tcPr marL="45720" marR="45720" marT="22860" marB="22860" anchor="ctr">
+                    <a:solidFill>
+                      <a:srgbClr val="EAF3EF"/>
+                    </a:solidFill>
+                  </a:tcPr>
+                </a:tc>
+                <a:tc>
+                  <a:txBody>
+                    <a:bodyPr/>
+                    <a:lstStyle/>
+                    <a:p>
+                      <a:pPr algn="l"/>
+                      <a:r>
+                        <a:rPr lang="en-US" sz="1100" dirty="0">
+                          <a:solidFill>
+                            <a:srgbClr val="1A1A1A"/>
+                          </a:solidFill>
+                          <a:latin typeface="Calibri"/>
+                        </a:rPr>
+                        <a:t>Mamaearth</a:t>
+                      </a:r>
+                    </a:p>
+                  </a:txBody>
+                  <a:tcPr marL="45720" marR="45720" marT="22860" marB="22860" anchor="ctr">
+                    <a:solidFill>
+                      <a:srgbClr val="EAF3EF"/>
+                    </a:solidFill>
+                  </a:tcPr>
+                </a:tc>
+                <a:tc>
+                  <a:txBody>
+                    <a:bodyPr/>
+                    <a:lstStyle/>
+                    <a:p>
+                      <a:pPr algn="l"/>
+                      <a:r>
+                        <a:rPr lang="en-US" sz="1100" dirty="0">
+                          <a:solidFill>
+                            <a:srgbClr val="1A1A1A"/>
+                          </a:solidFill>
+                          <a:latin typeface="Calibri"/>
+                        </a:rPr>
+                        <a:t>9.6</a:t>
+                      </a:r>
+                    </a:p>
+                  </a:txBody>
+                  <a:tcPr marL="45720" marR="45720" marT="22860" marB="22860" anchor="ctr">
+                    <a:solidFill>
+                      <a:srgbClr val="EAF3EF"/>
+                    </a:solidFill>
+                  </a:tcPr>
+                </a:tc>
+                <a:tc>
+                  <a:txBody>
+                    <a:bodyPr/>
+                    <a:lstStyle/>
+                    <a:p>
+                      <a:pPr algn="l"/>
+                      <a:r>
+                        <a:rPr lang="en-US" sz="1100" dirty="0">
+                          <a:solidFill>
+                            <a:srgbClr val="1A1A1A"/>
+                          </a:solidFill>
+                          <a:latin typeface="Calibri"/>
+                        </a:rPr>
+                        <a:t>12%</a:t>
+                      </a:r>
+                    </a:p>
+                  </a:txBody>
+                  <a:tcPr marL="45720" marR="45720" marT="22860" marB="22860" anchor="ctr">
+                    <a:solidFill>
+                      <a:srgbClr val="EAF3EF"/>
+                    </a:solidFill>
+                  </a:tcPr>
+                </a:tc>
+                <a:tc>
+                  <a:txBody>
+                    <a:bodyPr/>
+                    <a:lstStyle/>
+                    <a:p>
+                      <a:pPr algn="l"/>
+                      <a:r>
+                        <a:rPr lang="en-US" sz="1100" dirty="0">
+                          <a:solidFill>
+                            <a:srgbClr val="1A1A1A"/>
+                          </a:solidFill>
+                          <a:latin typeface="Calibri"/>
+                        </a:rPr>
+                        <a:t>+311</a:t>
+                      </a:r>
+                    </a:p>
+                  </a:txBody>
+                  <a:tcPr marL="45720" marR="45720" marT="22860" marB="22860" anchor="ctr">
+                    <a:solidFill>
+                      <a:srgbClr val="EAF3EF"/>
+                    </a:solidFill>
+                  </a:tcPr>
+                </a:tc>
+              </a:tr>
+              <a:tr h="411480">
+                <a:tc>
+                  <a:txBody>
+                    <a:bodyPr/>
+                    <a:lstStyle/>
+                    <a:p>
+                      <a:pPr algn="l"/>
+                      <a:r>
+                        <a:rPr lang="en-US" sz="1100" dirty="0">
+                          <a:solidFill>
+                            <a:srgbClr val="1A1A1A"/>
+                          </a:solidFill>
+                          <a:latin typeface="Calibri"/>
+                        </a:rPr>
+                        <a:t>5</a:t>
+                      </a:r>
+                    </a:p>
+                  </a:txBody>
+                  <a:tcPr marL="45720" marR="45720" marT="22860" marB="22860" anchor="ctr">
+                    <a:solidFill>
+                      <a:srgbClr val="FFFFFF"/>
+                    </a:solidFill>
+                  </a:tcPr>
+                </a:tc>
+                <a:tc>
+                  <a:txBody>
+                    <a:bodyPr/>
+                    <a:lstStyle/>
+                    <a:p>
+                      <a:pPr algn="l"/>
+                      <a:r>
+                        <a:rPr lang="en-US" sz="1100" dirty="0">
+                          <a:solidFill>
+                            <a:srgbClr val="1A1A1A"/>
+                          </a:solidFill>
+                          <a:latin typeface="Calibri"/>
+                        </a:rPr>
+                        <a:t>Clean &amp; Clear</a:t>
+                      </a:r>
+                    </a:p>
+                  </a:txBody>
+                  <a:tcPr marL="45720" marR="45720" marT="22860" marB="22860" anchor="ctr">
+                    <a:solidFill>
+                      <a:srgbClr val="FFFFFF"/>
+                    </a:solidFill>
+                  </a:tcPr>
+                </a:tc>
+                <a:tc>
+                  <a:txBody>
+                    <a:bodyPr/>
+                    <a:lstStyle/>
+                    <a:p>
+                      <a:pPr algn="l"/>
+                      <a:r>
+                        <a:rPr lang="en-US" sz="1100" dirty="0">
+                          <a:solidFill>
+                            <a:srgbClr val="1A1A1A"/>
+                          </a:solidFill>
+                          <a:latin typeface="Calibri"/>
+                        </a:rPr>
+                        <a:t>6.3</a:t>
+                      </a:r>
+                    </a:p>
+                  </a:txBody>
+                  <a:tcPr marL="45720" marR="45720" marT="22860" marB="22860" anchor="ctr">
+                    <a:solidFill>
+                      <a:srgbClr val="FFFFFF"/>
+                    </a:solidFill>
+                  </a:tcPr>
+                </a:tc>
+                <a:tc>
+                  <a:txBody>
+                    <a:bodyPr/>
+                    <a:lstStyle/>
+                    <a:p>
+                      <a:pPr algn="l"/>
+                      <a:r>
+                        <a:rPr lang="en-US" sz="1100" dirty="0">
+                          <a:solidFill>
+                            <a:srgbClr val="1A1A1A"/>
+                          </a:solidFill>
+                          <a:latin typeface="Calibri"/>
+                        </a:rPr>
+                        <a:t>8%</a:t>
+                      </a:r>
+                    </a:p>
+                  </a:txBody>
+                  <a:tcPr marL="45720" marR="45720" marT="22860" marB="22860" anchor="ctr">
+                    <a:solidFill>
+                      <a:srgbClr val="FFFFFF"/>
+                    </a:solidFill>
+                  </a:tcPr>
+                </a:tc>
+                <a:tc>
+                  <a:txBody>
+                    <a:bodyPr/>
+                    <a:lstStyle/>
+                    <a:p>
+                      <a:pPr algn="l"/>
+                      <a:r>
+                        <a:rPr lang="en-US" sz="1100" dirty="0">
+                          <a:solidFill>
+                            <a:srgbClr val="1A1A1A"/>
+                          </a:solidFill>
+                          <a:latin typeface="Calibri"/>
+                        </a:rPr>
+                        <a:t>+22</a:t>
+                      </a:r>
+                    </a:p>
+                  </a:txBody>
+                  <a:tcPr marL="45720" marR="45720" marT="22860" marB="22860" anchor="ctr">
+                    <a:solidFill>
+                      <a:srgbClr val="FFFFFF"/>
+                    </a:solidFill>
+                  </a:tcPr>
+                </a:tc>
+              </a:tr>
+              <a:tr h="411480">
+                <a:tc>
+                  <a:txBody>
+                    <a:bodyPr/>
+                    <a:lstStyle/>
+                    <a:p>
+                      <a:pPr algn="l"/>
+                      <a:r>
+                        <a:rPr lang="en-US" sz="1100" dirty="0">
+                          <a:solidFill>
+                            <a:srgbClr val="1A1A1A"/>
+                          </a:solidFill>
+                          <a:latin typeface="Calibri"/>
+                        </a:rPr>
+                        <a:t>16</a:t>
+                      </a:r>
+                    </a:p>
+                  </a:txBody>
+                  <a:tcPr marL="45720" marR="45720" marT="22860" marB="22860" anchor="ctr">
+                    <a:solidFill>
+                      <a:srgbClr val="EAF3EF"/>
+                    </a:solidFill>
+                  </a:tcPr>
+                </a:tc>
+                <a:tc>
+                  <a:txBody>
+                    <a:bodyPr/>
+                    <a:lstStyle/>
+                    <a:p>
+                      <a:pPr algn="l"/>
+                      <a:r>
+                        <a:rPr lang="en-US" sz="1100" dirty="0">
+                          <a:solidFill>
+                            <a:srgbClr val="1A1A1A"/>
+                          </a:solidFill>
+                          <a:latin typeface="Calibri"/>
+                        </a:rPr>
+                        <a:t>The Derma Co</a:t>
+                      </a:r>
+                    </a:p>
+                  </a:txBody>
+                  <a:tcPr marL="45720" marR="45720" marT="22860" marB="22860" anchor="ctr">
+                    <a:solidFill>
+                      <a:srgbClr val="EAF3EF"/>
+                    </a:solidFill>
+                  </a:tcPr>
+                </a:tc>
+                <a:tc>
+                  <a:txBody>
+                    <a:bodyPr/>
+                    <a:lstStyle/>
+                    <a:p>
+                      <a:pPr algn="l"/>
+                      <a:r>
+                        <a:rPr lang="en-US" sz="1100" dirty="0">
+                          <a:solidFill>
+                            <a:srgbClr val="1A1A1A"/>
+                          </a:solidFill>
+                          <a:latin typeface="Calibri"/>
+                        </a:rPr>
+                        <a:t>0.6</a:t>
+                      </a:r>
+                    </a:p>
+                  </a:txBody>
+                  <a:tcPr marL="45720" marR="45720" marT="22860" marB="22860" anchor="ctr">
+                    <a:solidFill>
+                      <a:srgbClr val="EAF3EF"/>
+                    </a:solidFill>
+                  </a:tcPr>
+                </a:tc>
+                <a:tc>
+                  <a:txBody>
+                    <a:bodyPr/>
+                    <a:lstStyle/>
+                    <a:p>
+                      <a:pPr algn="l"/>
+                      <a:r>
+                        <a:rPr lang="en-US" sz="1100" dirty="0">
+                          <a:solidFill>
+                            <a:srgbClr val="1A1A1A"/>
+                          </a:solidFill>
+                          <a:latin typeface="Calibri"/>
+                        </a:rPr>
+                        <a:t>0.7%</a:t>
+                      </a:r>
+                    </a:p>
+                  </a:txBody>
+                  <a:tcPr marL="45720" marR="45720" marT="22860" marB="22860" anchor="ctr">
+                    <a:solidFill>
+                      <a:srgbClr val="EAF3EF"/>
+                    </a:solidFill>
+                  </a:tcPr>
+                </a:tc>
+                <a:tc>
+                  <a:txBody>
+                    <a:bodyPr/>
+                    <a:lstStyle/>
+                    <a:p>
+                      <a:pPr algn="l"/>
+                      <a:r>
+                        <a:rPr lang="en-US" sz="1100" dirty="0">
+                          <a:solidFill>
+                            <a:srgbClr val="1A1A1A"/>
+                          </a:solidFill>
+                          <a:latin typeface="Calibri"/>
+                        </a:rPr>
+                        <a:t>+71</a:t>
+                      </a:r>
+                    </a:p>
+                  </a:txBody>
+                  <a:tcPr marL="45720" marR="45720" marT="22860" marB="22860" anchor="ctr">
+                    <a:solidFill>
+                      <a:srgbClr val="EAF3EF"/>
+                    </a:solidFill>
+                  </a:tcPr>
+                </a:tc>
+              </a:tr>
+            </a:tbl>
+          </a:graphicData>
+        </a:graphic>
+      </p:graphicFrame>
+      <p:sp>
+        <p:nvSpPr>
+          <p:cNvPr id="6" name="TextBox 6"/>
+          <p:cNvSpPr txBox="1"/>
+          <p:nvPr/>
+        </p:nvSpPr>
+        <p:spPr>
+          <a:xfrm>
+            <a:off x="6172200" y="1325880"/>
+            <a:ext cx="5440680" cy="320040"/>
+          </a:xfrm>
+          <a:prstGeom prst="rect">
+            <a:avLst/>
+          </a:prstGeom>
+          <a:noFill/>
+        </p:spPr>
+        <p:txBody>
+          <a:bodyPr wrap="square" anchor="t" lIns="0" tIns="0" rIns="0" bIns="0">
+            <a:noAutofit/>
+          </a:bodyPr>
+          <a:lstStyle/>
+          <a:p>
+            <a:pPr algn="l"/>
+            <a:r>
+              <a:rPr lang="en-US" sz="1400" b="1" dirty="0">
+                <a:solidFill>
+                  <a:srgbClr val="6D2E46"/>
+                </a:solidFill>
+                <a:latin typeface="Calibri"/>
+              </a:rPr>
+              <a:t>Shampoo — top competitors</a:t>
+            </a:r>
+          </a:p>
+        </p:txBody>
+      </p:sp>
+      <p:graphicFrame>
+        <p:nvGraphicFramePr>
+          <p:cNvPr id="7" name="Table 7"/>
+          <p:cNvGraphicFramePr>
+            <a:graphicFrameLocks noGrp="1"/>
+          </p:cNvGraphicFramePr>
+          <p:nvPr/>
+        </p:nvGraphicFramePr>
+        <p:xfrm>
+          <a:off x="6172200" y="1691640"/>
+          <a:ext cx="5440680" cy="2468880"/>
+        </p:xfrm>
+        <a:graphic>
+          <a:graphicData uri="http://schemas.openxmlformats.org/drawingml/2006/table">
+            <a:tbl>
+              <a:tblPr firstRow="1" bandRow="0">
+                <a:tableStyleId>{5C22544A-7EE6-4342-B048-85BDC9FD1C3A}</a:tableStyleId>
+              </a:tblPr>
+              <a:tblGrid>
+                <a:gridCol w="731520"/>
+                <a:gridCol w="2011680"/>
+                <a:gridCol w="1188720"/>
+                <a:gridCol w="960120"/>
+                <a:gridCol w="548640"/>
+              </a:tblGrid>
+              <a:tr h="411480">
+                <a:tc>
+                  <a:txBody>
+                    <a:bodyPr/>
+                    <a:lstStyle/>
+                    <a:p>
+                      <a:pPr algn="l"/>
+                      <a:r>
+                        <a:rPr lang="en-US" sz="1100" b="1" dirty="0">
+                          <a:solidFill>
+                            <a:srgbClr val="FFFFFF"/>
+                          </a:solidFill>
+                          <a:latin typeface="Calibri"/>
+                        </a:rPr>
+                        <a:t>Rank</a:t>
+                      </a:r>
+                    </a:p>
+                  </a:txBody>
+                  <a:tcPr marL="45720" marR="45720" marT="22860" marB="22860" anchor="ctr">
+                    <a:solidFill>
+                      <a:srgbClr val="2F3C7E"/>
+                    </a:solidFill>
+                  </a:tcPr>
+                </a:tc>
+                <a:tc>
+                  <a:txBody>
+                    <a:bodyPr/>
+                    <a:lstStyle/>
+                    <a:p>
+                      <a:pPr algn="l"/>
+                      <a:r>
+                        <a:rPr lang="en-US" sz="1100" b="1" dirty="0">
+                          <a:solidFill>
+                            <a:srgbClr val="FFFFFF"/>
+                          </a:solidFill>
+                          <a:latin typeface="Calibri"/>
+                        </a:rPr>
+                        <a:t>Brand</a:t>
+                      </a:r>
+                    </a:p>
+                  </a:txBody>
+                  <a:tcPr marL="45720" marR="45720" marT="22860" marB="22860" anchor="ctr">
+                    <a:solidFill>
+                      <a:srgbClr val="2F3C7E"/>
+                    </a:solidFill>
+                  </a:tcPr>
+                </a:tc>
+                <a:tc>
+                  <a:txBody>
+                    <a:bodyPr/>
+                    <a:lstStyle/>
+                    <a:p>
+                      <a:pPr algn="l"/>
+                      <a:r>
+                        <a:rPr lang="en-US" sz="1100" b="1" dirty="0">
+                          <a:solidFill>
+                            <a:srgbClr val="FFFFFF"/>
+                          </a:solidFill>
+                          <a:latin typeface="Calibri"/>
+                        </a:rPr>
+                        <a:t>Value (Cr)</a:t>
+                      </a:r>
+                    </a:p>
+                  </a:txBody>
+                  <a:tcPr marL="45720" marR="45720" marT="22860" marB="22860" anchor="ctr">
+                    <a:solidFill>
+                      <a:srgbClr val="2F3C7E"/>
+                    </a:solidFill>
+                  </a:tcPr>
+                </a:tc>
+                <a:tc>
+                  <a:txBody>
+                    <a:bodyPr/>
+                    <a:lstStyle/>
+                    <a:p>
+                      <a:pPr algn="l"/>
+                      <a:r>
+                        <a:rPr lang="en-US" sz="1100" b="1" dirty="0">
+                          <a:solidFill>
+                            <a:srgbClr val="FFFFFF"/>
+                          </a:solidFill>
+                          <a:latin typeface="Calibri"/>
+                        </a:rPr>
+                        <a:t>MS Val %</a:t>
+                      </a:r>
+                    </a:p>
+                  </a:txBody>
+                  <a:tcPr marL="45720" marR="45720" marT="22860" marB="22860" anchor="ctr">
+                    <a:solidFill>
+                      <a:srgbClr val="2F3C7E"/>
+                    </a:solidFill>
+                  </a:tcPr>
+                </a:tc>
+                <a:tc>
+                  <a:txBody>
+                    <a:bodyPr/>
+                    <a:lstStyle/>
+                    <a:p>
+                      <a:pPr algn="l"/>
+                      <a:r>
+                        <a:rPr lang="en-US" sz="1100" b="1" dirty="0">
+                          <a:solidFill>
+                            <a:srgbClr val="FFFFFF"/>
+                          </a:solidFill>
+                          <a:latin typeface="Calibri"/>
+                        </a:rPr>
+                        <a:t>YoY (bps)</a:t>
+                      </a:r>
+                    </a:p>
+                  </a:txBody>
+                  <a:tcPr marL="45720" marR="45720" marT="22860" marB="22860" anchor="ctr">
+                    <a:solidFill>
+                      <a:srgbClr val="2F3C7E"/>
+                    </a:solidFill>
+                  </a:tcPr>
+                </a:tc>
+              </a:tr>
+              <a:tr h="411480">
+                <a:tc>
+                  <a:txBody>
+                    <a:bodyPr/>
+                    <a:lstStyle/>
+                    <a:p>
+                      <a:pPr algn="l"/>
+                      <a:r>
+                        <a:rPr lang="en-US" sz="1100" dirty="0">
+                          <a:solidFill>
+                            <a:srgbClr val="1A1A1A"/>
+                          </a:solidFill>
+                          <a:latin typeface="Calibri"/>
+                        </a:rPr>
+                        <a:t>1</a:t>
+                      </a:r>
+                    </a:p>
+                  </a:txBody>
+                  <a:tcPr marL="45720" marR="45720" marT="22860" marB="22860" anchor="ctr">
+                    <a:solidFill>
+                      <a:srgbClr val="FFFFFF"/>
+                    </a:solidFill>
+                  </a:tcPr>
+                </a:tc>
+                <a:tc>
+                  <a:txBody>
+                    <a:bodyPr/>
+                    <a:lstStyle/>
+                    <a:p>
+                      <a:pPr algn="l"/>
+                      <a:r>
+                        <a:rPr lang="en-US" sz="1100" dirty="0">
+                          <a:solidFill>
+                            <a:srgbClr val="1A1A1A"/>
+                          </a:solidFill>
+                          <a:latin typeface="Calibri"/>
+                        </a:rPr>
+                        <a:t>Dove</a:t>
+                      </a:r>
+                    </a:p>
+                  </a:txBody>
+                  <a:tcPr marL="45720" marR="45720" marT="22860" marB="22860" anchor="ctr">
+                    <a:solidFill>
+                      <a:srgbClr val="FFFFFF"/>
+                    </a:solidFill>
+                  </a:tcPr>
+                </a:tc>
+                <a:tc>
+                  <a:txBody>
+                    <a:bodyPr/>
+                    <a:lstStyle/>
+                    <a:p>
+                      <a:pPr algn="l"/>
+                      <a:r>
+                        <a:rPr lang="en-US" sz="1100" dirty="0">
+                          <a:solidFill>
+                            <a:srgbClr val="1A1A1A"/>
+                          </a:solidFill>
+                          <a:latin typeface="Calibri"/>
+                        </a:rPr>
+                        <a:t>29.6</a:t>
+                      </a:r>
+                    </a:p>
+                  </a:txBody>
+                  <a:tcPr marL="45720" marR="45720" marT="22860" marB="22860" anchor="ctr">
+                    <a:solidFill>
+                      <a:srgbClr val="FFFFFF"/>
+                    </a:solidFill>
+                  </a:tcPr>
+                </a:tc>
+                <a:tc>
+                  <a:txBody>
+                    <a:bodyPr/>
+                    <a:lstStyle/>
+                    <a:p>
+                      <a:pPr algn="l"/>
+                      <a:r>
+                        <a:rPr lang="en-US" sz="1100" dirty="0">
+                          <a:solidFill>
+                            <a:srgbClr val="1A1A1A"/>
+                          </a:solidFill>
+                          <a:latin typeface="Calibri"/>
+                        </a:rPr>
+                        <a:t>18%</a:t>
+                      </a:r>
+                    </a:p>
+                  </a:txBody>
+                  <a:tcPr marL="45720" marR="45720" marT="22860" marB="22860" anchor="ctr">
+                    <a:solidFill>
+                      <a:srgbClr val="FFFFFF"/>
+                    </a:solidFill>
+                  </a:tcPr>
+                </a:tc>
+                <a:tc>
+                  <a:txBody>
+                    <a:bodyPr/>
+                    <a:lstStyle/>
+                    <a:p>
+                      <a:pPr algn="l"/>
+                      <a:r>
+                        <a:rPr lang="en-US" sz="1100" dirty="0">
+                          <a:solidFill>
+                            <a:srgbClr val="1A1A1A"/>
+                          </a:solidFill>
+                          <a:latin typeface="Calibri"/>
+                        </a:rPr>
+                        <a:t>+20</a:t>
+                      </a:r>
+                    </a:p>
+                  </a:txBody>
+                  <a:tcPr marL="45720" marR="45720" marT="22860" marB="22860" anchor="ctr">
+                    <a:solidFill>
+                      <a:srgbClr val="FFFFFF"/>
+                    </a:solidFill>
+                  </a:tcPr>
+                </a:tc>
+              </a:tr>
+              <a:tr h="411480">
+                <a:tc>
+                  <a:txBody>
+                    <a:bodyPr/>
+                    <a:lstStyle/>
+                    <a:p>
+                      <a:pPr algn="l"/>
+                      <a:r>
+                        <a:rPr lang="en-US" sz="1100" dirty="0">
+                          <a:solidFill>
+                            <a:srgbClr val="1A1A1A"/>
+                          </a:solidFill>
+                          <a:latin typeface="Calibri"/>
+                        </a:rPr>
+                        <a:t>2</a:t>
+                      </a:r>
+                    </a:p>
+                  </a:txBody>
+                  <a:tcPr marL="45720" marR="45720" marT="22860" marB="22860" anchor="ctr">
+                    <a:solidFill>
+                      <a:srgbClr val="FFFFFF"/>
+                    </a:solidFill>
+                  </a:tcPr>
+                </a:tc>
+                <a:tc>
+                  <a:txBody>
+                    <a:bodyPr/>
+                    <a:lstStyle/>
+                    <a:p>
+                      <a:pPr algn="l"/>
+                      <a:r>
+                        <a:rPr lang="en-US" sz="1100" dirty="0">
+                          <a:solidFill>
+                            <a:srgbClr val="1A1A1A"/>
+                          </a:solidFill>
+                          <a:latin typeface="Calibri"/>
+                        </a:rPr>
+                        <a:t>L'Oreal Paris</a:t>
+                      </a:r>
+                    </a:p>
+                  </a:txBody>
+                  <a:tcPr marL="45720" marR="45720" marT="22860" marB="22860" anchor="ctr">
+                    <a:solidFill>
+                      <a:srgbClr val="FFFFFF"/>
+                    </a:solidFill>
+                  </a:tcPr>
+                </a:tc>
+                <a:tc>
+                  <a:txBody>
+                    <a:bodyPr/>
+                    <a:lstStyle/>
+                    <a:p>
+                      <a:pPr algn="l"/>
+                      <a:r>
+                        <a:rPr lang="en-US" sz="1100" dirty="0">
+                          <a:solidFill>
+                            <a:srgbClr val="1A1A1A"/>
+                          </a:solidFill>
+                          <a:latin typeface="Calibri"/>
+                        </a:rPr>
+                        <a:t>22.1</a:t>
+                      </a:r>
+                    </a:p>
+                  </a:txBody>
+                  <a:tcPr marL="45720" marR="45720" marT="22860" marB="22860" anchor="ctr">
+                    <a:solidFill>
+                      <a:srgbClr val="FFFFFF"/>
+                    </a:solidFill>
+                  </a:tcPr>
+                </a:tc>
+                <a:tc>
+                  <a:txBody>
+                    <a:bodyPr/>
+                    <a:lstStyle/>
+                    <a:p>
+                      <a:pPr algn="l"/>
+                      <a:r>
+                        <a:rPr lang="en-US" sz="1100" dirty="0">
+                          <a:solidFill>
+                            <a:srgbClr val="1A1A1A"/>
+                          </a:solidFill>
+                          <a:latin typeface="Calibri"/>
+                        </a:rPr>
+                        <a:t>13%</a:t>
+                      </a:r>
+                    </a:p>
+                  </a:txBody>
+                  <a:tcPr marL="45720" marR="45720" marT="22860" marB="22860" anchor="ctr">
+                    <a:solidFill>
+                      <a:srgbClr val="FFFFFF"/>
+                    </a:solidFill>
+                  </a:tcPr>
+                </a:tc>
+                <a:tc>
+                  <a:txBody>
+                    <a:bodyPr/>
+                    <a:lstStyle/>
+                    <a:p>
+                      <a:pPr algn="l"/>
+                      <a:r>
+                        <a:rPr lang="en-US" sz="1100" dirty="0">
+                          <a:solidFill>
+                            <a:srgbClr val="1A1A1A"/>
+                          </a:solidFill>
+                          <a:latin typeface="Calibri"/>
+                        </a:rPr>
+                        <a:t>+130</a:t>
+                      </a:r>
+                    </a:p>
+                  </a:txBody>
+                  <a:tcPr marL="45720" marR="45720" marT="22860" marB="22860" anchor="ctr">
+                    <a:solidFill>
+                      <a:srgbClr val="FFFFFF"/>
+                    </a:solidFill>
+                  </a:tcPr>
+                </a:tc>
+              </a:tr>
+              <a:tr h="411480">
+                <a:tc>
+                  <a:txBody>
+                    <a:bodyPr/>
+                    <a:lstStyle/>
+                    <a:p>
+                      <a:pPr algn="l"/>
+                      <a:r>
+                        <a:rPr lang="en-US" sz="1100" dirty="0">
+                          <a:solidFill>
+                            <a:srgbClr val="1A1A1A"/>
+                          </a:solidFill>
+                          <a:latin typeface="Calibri"/>
+                        </a:rPr>
+                        <a:t>3</a:t>
+                      </a:r>
+                    </a:p>
+                  </a:txBody>
+                  <a:tcPr marL="45720" marR="45720" marT="22860" marB="22860" anchor="ctr">
+                    <a:solidFill>
+                      <a:srgbClr val="FFFFFF"/>
+                    </a:solidFill>
+                  </a:tcPr>
+                </a:tc>
+                <a:tc>
+                  <a:txBody>
+                    <a:bodyPr/>
+                    <a:lstStyle/>
+                    <a:p>
+                      <a:pPr algn="l"/>
+                      <a:r>
+                        <a:rPr lang="en-US" sz="1100" dirty="0">
+                          <a:solidFill>
+                            <a:srgbClr val="1A1A1A"/>
+                          </a:solidFill>
+                          <a:latin typeface="Calibri"/>
+                        </a:rPr>
+                        <a:t>Head &amp; Shoulders</a:t>
+                      </a:r>
+                    </a:p>
+                  </a:txBody>
+                  <a:tcPr marL="45720" marR="45720" marT="22860" marB="22860" anchor="ctr">
+                    <a:solidFill>
+                      <a:srgbClr val="FFFFFF"/>
+                    </a:solidFill>
+                  </a:tcPr>
+                </a:tc>
+                <a:tc>
+                  <a:txBody>
+                    <a:bodyPr/>
+                    <a:lstStyle/>
+                    <a:p>
+                      <a:pPr algn="l"/>
+                      <a:r>
+                        <a:rPr lang="en-US" sz="1100" dirty="0">
+                          <a:solidFill>
+                            <a:srgbClr val="1A1A1A"/>
+                          </a:solidFill>
+                          <a:latin typeface="Calibri"/>
+                        </a:rPr>
+                        <a:t>19.0</a:t>
+                      </a:r>
+                    </a:p>
+                  </a:txBody>
+                  <a:tcPr marL="45720" marR="45720" marT="22860" marB="22860" anchor="ctr">
+                    <a:solidFill>
+                      <a:srgbClr val="FFFFFF"/>
+                    </a:solidFill>
+                  </a:tcPr>
+                </a:tc>
+                <a:tc>
+                  <a:txBody>
+                    <a:bodyPr/>
+                    <a:lstStyle/>
+                    <a:p>
+                      <a:pPr algn="l"/>
+                      <a:r>
+                        <a:rPr lang="en-US" sz="1100" dirty="0">
+                          <a:solidFill>
+                            <a:srgbClr val="1A1A1A"/>
+                          </a:solidFill>
+                          <a:latin typeface="Calibri"/>
+                        </a:rPr>
+                        <a:t>11%</a:t>
+                      </a:r>
+                    </a:p>
+                  </a:txBody>
+                  <a:tcPr marL="45720" marR="45720" marT="22860" marB="22860" anchor="ctr">
+                    <a:solidFill>
+                      <a:srgbClr val="FFFFFF"/>
+                    </a:solidFill>
+                  </a:tcPr>
+                </a:tc>
+                <a:tc>
+                  <a:txBody>
+                    <a:bodyPr/>
+                    <a:lstStyle/>
+                    <a:p>
+                      <a:pPr algn="l"/>
+                      <a:r>
+                        <a:rPr lang="en-US" sz="1100" dirty="0">
+                          <a:solidFill>
+                            <a:srgbClr val="1A1A1A"/>
+                          </a:solidFill>
+                          <a:latin typeface="Calibri"/>
+                        </a:rPr>
+                        <a:t>+200</a:t>
+                      </a:r>
+                    </a:p>
+                  </a:txBody>
+                  <a:tcPr marL="45720" marR="45720" marT="22860" marB="22860" anchor="ctr">
+                    <a:solidFill>
+                      <a:srgbClr val="FFFFFF"/>
+                    </a:solidFill>
+                  </a:tcPr>
+                </a:tc>
+              </a:tr>
+              <a:tr h="411480">
+                <a:tc>
+                  <a:txBody>
+                    <a:bodyPr/>
+                    <a:lstStyle/>
+                    <a:p>
+                      <a:pPr algn="l"/>
+                      <a:r>
+                        <a:rPr lang="en-US" sz="1100" dirty="0">
+                          <a:solidFill>
+                            <a:srgbClr val="1A1A1A"/>
+                          </a:solidFill>
+                          <a:latin typeface="Calibri"/>
+                        </a:rPr>
+                        <a:t>4</a:t>
+                      </a:r>
+                    </a:p>
+                  </a:txBody>
+                  <a:tcPr marL="45720" marR="45720" marT="22860" marB="22860" anchor="ctr">
+                    <a:solidFill>
+                      <a:srgbClr val="FFFFFF"/>
+                    </a:solidFill>
+                  </a:tcPr>
+                </a:tc>
+                <a:tc>
+                  <a:txBody>
+                    <a:bodyPr/>
+                    <a:lstStyle/>
+                    <a:p>
+                      <a:pPr algn="l"/>
+                      <a:r>
+                        <a:rPr lang="en-US" sz="1100" dirty="0">
+                          <a:solidFill>
+                            <a:srgbClr val="1A1A1A"/>
+                          </a:solidFill>
+                          <a:latin typeface="Calibri"/>
+                        </a:rPr>
+                        <a:t>Tresemme</a:t>
+                      </a:r>
+                    </a:p>
+                  </a:txBody>
+                  <a:tcPr marL="45720" marR="45720" marT="22860" marB="22860" anchor="ctr">
+                    <a:solidFill>
+                      <a:srgbClr val="FFFFFF"/>
+                    </a:solidFill>
+                  </a:tcPr>
+                </a:tc>
+                <a:tc>
+                  <a:txBody>
+                    <a:bodyPr/>
+                    <a:lstStyle/>
+                    <a:p>
+                      <a:pPr algn="l"/>
+                      <a:r>
+                        <a:rPr lang="en-US" sz="1100" dirty="0">
+                          <a:solidFill>
+                            <a:srgbClr val="1A1A1A"/>
+                          </a:solidFill>
+                          <a:latin typeface="Calibri"/>
+                        </a:rPr>
+                        <a:t>17.3</a:t>
+                      </a:r>
+                    </a:p>
+                  </a:txBody>
+                  <a:tcPr marL="45720" marR="45720" marT="22860" marB="22860" anchor="ctr">
+                    <a:solidFill>
+                      <a:srgbClr val="FFFFFF"/>
+                    </a:solidFill>
+                  </a:tcPr>
+                </a:tc>
+                <a:tc>
+                  <a:txBody>
+                    <a:bodyPr/>
+                    <a:lstStyle/>
+                    <a:p>
+                      <a:pPr algn="l"/>
+                      <a:r>
+                        <a:rPr lang="en-US" sz="1100" dirty="0">
+                          <a:solidFill>
+                            <a:srgbClr val="1A1A1A"/>
+                          </a:solidFill>
+                          <a:latin typeface="Calibri"/>
+                        </a:rPr>
+                        <a:t>10%</a:t>
+                      </a:r>
+                    </a:p>
+                  </a:txBody>
+                  <a:tcPr marL="45720" marR="45720" marT="22860" marB="22860" anchor="ctr">
+                    <a:solidFill>
+                      <a:srgbClr val="FFFFFF"/>
+                    </a:solidFill>
+                  </a:tcPr>
+                </a:tc>
+                <a:tc>
+                  <a:txBody>
+                    <a:bodyPr/>
+                    <a:lstStyle/>
+                    <a:p>
+                      <a:pPr algn="l"/>
+                      <a:r>
+                        <a:rPr lang="en-US" sz="1100" dirty="0">
+                          <a:solidFill>
+                            <a:srgbClr val="1A1A1A"/>
+                          </a:solidFill>
+                          <a:latin typeface="Calibri"/>
+                        </a:rPr>
+                        <a:t>+140</a:t>
+                      </a:r>
+                    </a:p>
+                  </a:txBody>
+                  <a:tcPr marL="45720" marR="45720" marT="22860" marB="22860" anchor="ctr">
+                    <a:solidFill>
+                      <a:srgbClr val="FFFFFF"/>
+                    </a:solidFill>
+                  </a:tcPr>
+                </a:tc>
+              </a:tr>
+              <a:tr h="411480">
+                <a:tc>
+                  <a:txBody>
+                    <a:bodyPr/>
+                    <a:lstStyle/>
+                    <a:p>
+                      <a:pPr algn="l"/>
+                      <a:r>
+                        <a:rPr lang="en-US" sz="1100" dirty="0">
+                          <a:solidFill>
+                            <a:srgbClr val="1A1A1A"/>
+                          </a:solidFill>
+                          <a:latin typeface="Calibri"/>
+                        </a:rPr>
+                        <a:t>7</a:t>
+                      </a:r>
+                    </a:p>
+                  </a:txBody>
+                  <a:tcPr marL="45720" marR="45720" marT="22860" marB="22860" anchor="ctr">
+                    <a:solidFill>
+                      <a:srgbClr val="EAF3EF"/>
+                    </a:solidFill>
+                  </a:tcPr>
+                </a:tc>
+                <a:tc>
+                  <a:txBody>
+                    <a:bodyPr/>
+                    <a:lstStyle/>
+                    <a:p>
+                      <a:pPr algn="l"/>
+                      <a:r>
+                        <a:rPr lang="en-US" sz="1100" dirty="0">
+                          <a:solidFill>
+                            <a:srgbClr val="1A1A1A"/>
+                          </a:solidFill>
+                          <a:latin typeface="Calibri"/>
+                        </a:rPr>
+                        <a:t>Mamaearth</a:t>
+                      </a:r>
+                    </a:p>
+                  </a:txBody>
+                  <a:tcPr marL="45720" marR="45720" marT="22860" marB="22860" anchor="ctr">
+                    <a:solidFill>
+                      <a:srgbClr val="EAF3EF"/>
+                    </a:solidFill>
+                  </a:tcPr>
+                </a:tc>
+                <a:tc>
+                  <a:txBody>
+                    <a:bodyPr/>
+                    <a:lstStyle/>
+                    <a:p>
+                      <a:pPr algn="l"/>
+                      <a:r>
+                        <a:rPr lang="en-US" sz="1100" dirty="0">
+                          <a:solidFill>
+                            <a:srgbClr val="1A1A1A"/>
+                          </a:solidFill>
+                          <a:latin typeface="Calibri"/>
+                        </a:rPr>
+                        <a:t>6.5</a:t>
+                      </a:r>
+                    </a:p>
+                  </a:txBody>
+                  <a:tcPr marL="45720" marR="45720" marT="22860" marB="22860" anchor="ctr">
+                    <a:solidFill>
+                      <a:srgbClr val="EAF3EF"/>
+                    </a:solidFill>
+                  </a:tcPr>
+                </a:tc>
+                <a:tc>
+                  <a:txBody>
+                    <a:bodyPr/>
+                    <a:lstStyle/>
+                    <a:p>
+                      <a:pPr algn="l"/>
+                      <a:r>
+                        <a:rPr lang="en-US" sz="1100" dirty="0">
+                          <a:solidFill>
+                            <a:srgbClr val="1A1A1A"/>
+                          </a:solidFill>
+                          <a:latin typeface="Calibri"/>
+                        </a:rPr>
+                        <a:t>4%</a:t>
+                      </a:r>
+                    </a:p>
+                  </a:txBody>
+                  <a:tcPr marL="45720" marR="45720" marT="22860" marB="22860" anchor="ctr">
+                    <a:solidFill>
+                      <a:srgbClr val="EAF3EF"/>
+                    </a:solidFill>
+                  </a:tcPr>
+                </a:tc>
+                <a:tc>
+                  <a:txBody>
+                    <a:bodyPr/>
+                    <a:lstStyle/>
+                    <a:p>
+                      <a:pPr algn="l"/>
+                      <a:r>
+                        <a:rPr lang="en-US" sz="1100" dirty="0">
+                          <a:solidFill>
+                            <a:srgbClr val="1A1A1A"/>
+                          </a:solidFill>
+                          <a:latin typeface="Calibri"/>
+                        </a:rPr>
+                        <a:t>+130</a:t>
+                      </a:r>
+                    </a:p>
+                  </a:txBody>
+                  <a:tcPr marL="45720" marR="45720" marT="22860" marB="22860" anchor="ctr">
+                    <a:solidFill>
+                      <a:srgbClr val="EAF3EF"/>
+                    </a:solidFill>
+                  </a:tcPr>
+                </a:tc>
+              </a:tr>
+            </a:tbl>
+          </a:graphicData>
+        </a:graphic>
+      </p:graphicFrame>
+      <p:sp>
+        <p:nvSpPr>
+          <p:cNvPr id="8" name="Rect 8"/>
+          <p:cNvSpPr/>
+          <p:nvPr/>
+        </p:nvSpPr>
+        <p:spPr>
+          <a:xfrm>
+            <a:off x="548640" y="4663440"/>
+            <a:ext cx="11064240" cy="1463040"/>
+          </a:xfrm>
+          <a:prstGeom prst="roundRect">
+            <a:avLst/>
+          </a:prstGeom>
+          <a:solidFill>
+            <a:srgbClr val="ECE2D0"/>
+          </a:solidFill>
+          <a:ln>
+            <a:noFill/>
+          </a:ln>
+          <a:effectLst/>
+        </p:spPr>
+        <p:txBody>
+          <a:bodyPr/>
+          <a:lstStyle/>
+          <a:p/>
+        </p:txBody>
+      </p:sp>
+      <p:sp>
+        <p:nvSpPr>
+          <p:cNvPr id="9" name="TextBox 9"/>
+          <p:cNvSpPr txBox="1"/>
+          <p:nvPr/>
+        </p:nvSpPr>
+        <p:spPr>
+          <a:xfrm>
+            <a:off x="822960" y="4828032"/>
+            <a:ext cx="10515600" cy="1143000"/>
+          </a:xfrm>
+          <a:prstGeom prst="rect">
+            <a:avLst/>
+          </a:prstGeom>
+          <a:noFill/>
+        </p:spPr>
+        <p:txBody>
+          <a:bodyPr wrap="square" anchor="t" lIns="0" tIns="0" rIns="0" bIns="0">
+            <a:noAutofit/>
+          </a:bodyPr>
+          <a:lstStyle/>
+          <a:p>
+            <a:pPr algn="l"/>
+            <a:r>
+              <a:rPr lang="en-US" sz="1300" b="1" dirty="0">
+                <a:solidFill>
+                  <a:srgbClr val="6D2E46"/>
+                </a:solidFill>
+                <a:latin typeface="Calibri"/>
+              </a:rPr>
+              <a:t>Facewash: </a:t>
+            </a:r>
+            <a:r>
+              <a:rPr lang="en-US" sz="1250" dirty="0">
+                <a:solidFill>
+                  <a:srgbClr val="1A1A1A"/>
+                </a:solidFill>
+                <a:latin typeface="Calibri"/>
+              </a:rPr>
+              <a:t>Mamaearth ranks #4 nationally and is growing share fastest of the top 5 (+311bps YoY vs next-best Garnier +55bps) — validates the MT bright-spot story at national level too.</a:t>
+            </a:r>
+          </a:p>
+          <a:p>
+            <a:pPr algn="l"/>
+            <a:r>
+              <a:rPr lang="en-US" sz="1300" b="1" dirty="0">
+                <a:solidFill>
+                  <a:srgbClr val="6D2E46"/>
+                </a:solidFill>
+                <a:latin typeface="Calibri"/>
+              </a:rPr>
+              <a:t>Shampoo: </a:t>
+            </a:r>
+            <a:r>
+              <a:rPr lang="en-US" sz="1250" dirty="0">
+                <a:solidFill>
+                  <a:srgbClr val="1A1A1A"/>
+                </a:solidFill>
+                <a:latin typeface="Calibri"/>
+              </a:rPr>
+              <a:t>Mamaearth is #7 nationally; category leaders (Dove, H&amp;S) are also growing double-digit bps YoY — this is a crowded, well-defended category, consistent with GT-specific weakness found in the MT vs GT panel.</a:t>
+            </a:r>
+          </a:p>
+        </p:txBody>
+      </p:sp>
+    </p:spTree>
+  </p:cSld>
+  <p:clrMapOvr>
+    <a:masterClrMapping/>
+  </p:clrMapOvr>
+</p:sld>
+</file>
+
+<file path=ppt/slides/slide7.xml><?xml version="1.0" encoding="utf-8"?>
+<p:sld xmlns:a="http://schemas.openxmlformats.org/drawingml/2006/main" xmlns:r="http://schemas.openxmlformats.org/officeDocument/2006/relationships" xmlns:p="http://schemas.openxmlformats.org/presentationml/2006/main">
+  <p:cSld>
+    <p:bg>
+      <p:bgPr>
+        <a:solidFill>
+          <a:srgbClr val="FFFFFF"/>
+        </a:solidFill>
+        <a:effectLst/>
+      </p:bgPr>
+    </p:bg>
+    <p:spTree>
+      <p:nvGrpSpPr>
+        <p:cNvPr id="1" name=""/>
+        <p:cNvGrpSpPr/>
+        <p:nvPr/>
+      </p:nvGrpSpPr>
+      <p:grpSpPr>
+        <a:xfrm>
+          <a:off x="0" y="0"/>
+          <a:ext cx="0" cy="0"/>
+          <a:chOff x="0" y="0"/>
+          <a:chExt cx="0" cy="0"/>
+        </a:xfrm>
+      </p:grpSpPr>
+      <p:sp>
+        <p:nvSpPr>
+          <p:cNvPr id="2" name="TextBox 2"/>
+          <p:cNvSpPr txBox="1"/>
+          <p:nvPr/>
+        </p:nvSpPr>
+        <p:spPr>
+          <a:xfrm>
+            <a:off x="548640" y="320040"/>
+            <a:ext cx="10972800" cy="548640"/>
+          </a:xfrm>
+          <a:prstGeom prst="rect">
+            <a:avLst/>
+          </a:prstGeom>
+          <a:noFill/>
+        </p:spPr>
+        <p:txBody>
+          <a:bodyPr wrap="square" anchor="t" lIns="0" tIns="0" rIns="0" bIns="0">
+            <a:noAutofit/>
+          </a:bodyPr>
+          <a:lstStyle/>
+          <a:p>
+            <a:pPr algn="l"/>
+            <a:r>
+              <a:rPr lang="en-US" sz="2600" b="1" dirty="0">
+                <a:solidFill>
+                  <a:srgbClr val="1A1A1A"/>
+                </a:solidFill>
+                <a:latin typeface="Cambria"/>
+              </a:rPr>
+              <a:t>Pack-Size &amp; State White Space (Nielsen, May'26)</a:t>
+            </a:r>
+          </a:p>
+        </p:txBody>
+      </p:sp>
+      <p:sp>
+        <p:nvSpPr>
+          <p:cNvPr id="3" name="TextBox 3"/>
+          <p:cNvSpPr txBox="1"/>
+          <p:nvPr/>
+        </p:nvSpPr>
+        <p:spPr>
+          <a:xfrm>
+            <a:off x="548640" y="960120"/>
+            <a:ext cx="5486400" cy="320040"/>
+          </a:xfrm>
+          <a:prstGeom prst="rect">
+            <a:avLst/>
+          </a:prstGeom>
+          <a:noFill/>
+        </p:spPr>
+        <p:txBody>
+          <a:bodyPr wrap="square" anchor="t" lIns="0" tIns="0" rIns="0" bIns="0">
+            <a:noAutofit/>
+          </a:bodyPr>
+          <a:lstStyle/>
+          <a:p>
+            <a:pPr algn="l"/>
+            <a:r>
+              <a:rPr lang="en-US" sz="1400" b="1" dirty="0">
+                <a:solidFill>
+                  <a:srgbClr val="6D2E46"/>
+                </a:solidFill>
+                <a:latin typeface="Calibri"/>
+              </a:rPr>
+              <a:t>Mamaearth Facewash — pack size</a:t>
+            </a:r>
+          </a:p>
+        </p:txBody>
+      </p:sp>
+      <p:graphicFrame>
+        <p:nvGraphicFramePr>
+          <p:cNvPr id="4" name="Table 4"/>
+          <p:cNvGraphicFramePr>
+            <a:graphicFrameLocks noGrp="1"/>
+          </p:cNvGraphicFramePr>
+          <p:nvPr/>
+        </p:nvGraphicFramePr>
+        <p:xfrm>
+          <a:off x="548640" y="1325880"/>
+          <a:ext cx="11064240" cy="2468880"/>
+        </p:xfrm>
+        <a:graphic>
+          <a:graphicData uri="http://schemas.openxmlformats.org/drawingml/2006/table">
+            <a:tbl>
+              <a:tblPr firstRow="1" bandRow="0">
+                <a:tableStyleId>{5C22544A-7EE6-4342-B048-85BDC9FD1C3A}</a:tableStyleId>
+              </a:tblPr>
+              <a:tblGrid>
+                <a:gridCol w="1371600"/>
+                <a:gridCol w="3017520"/>
+                <a:gridCol w="1828800"/>
+                <a:gridCol w="4846320"/>
+              </a:tblGrid>
+              <a:tr h="411480">
+                <a:tc>
+                  <a:txBody>
+                    <a:bodyPr/>
+                    <a:lstStyle/>
+                    <a:p>
+                      <a:pPr algn="l"/>
+                      <a:r>
+                        <a:rPr lang="en-US" sz="1150" b="1" dirty="0">
+                          <a:solidFill>
+                            <a:srgbClr val="FFFFFF"/>
+                          </a:solidFill>
+                          <a:latin typeface="Calibri"/>
+                        </a:rPr>
+                        <a:t>Pack</a:t>
+                      </a:r>
+                    </a:p>
+                  </a:txBody>
+                  <a:tcPr marL="45720" marR="45720" marT="22860" marB="22860" anchor="ctr">
+                    <a:solidFill>
+                      <a:srgbClr val="2F3C7E"/>
+                    </a:solidFill>
+                  </a:tcPr>
+                </a:tc>
+                <a:tc>
+                  <a:txBody>
+                    <a:bodyPr/>
+                    <a:lstStyle/>
+                    <a:p>
+                      <a:pPr algn="l"/>
+                      <a:r>
+                        <a:rPr lang="en-US" sz="1150" b="1" dirty="0">
+                          <a:solidFill>
+                            <a:srgbClr val="FFFFFF"/>
+                          </a:solidFill>
+                          <a:latin typeface="Calibri"/>
+                        </a:rPr>
+                        <a:t>% of Mamaearth Facewash</a:t>
+                      </a:r>
+                    </a:p>
+                  </a:txBody>
+                  <a:tcPr marL="45720" marR="45720" marT="22860" marB="22860" anchor="ctr">
+                    <a:solidFill>
+                      <a:srgbClr val="2F3C7E"/>
+                    </a:solidFill>
+                  </a:tcPr>
+                </a:tc>
+                <a:tc>
+                  <a:txBody>
+                    <a:bodyPr/>
+                    <a:lstStyle/>
+                    <a:p>
+                      <a:pPr algn="l"/>
+                      <a:r>
+                        <a:rPr lang="en-US" sz="1150" b="1" dirty="0">
+                          <a:solidFill>
+                            <a:srgbClr val="FFFFFF"/>
+                          </a:solidFill>
+                          <a:latin typeface="Calibri"/>
+                        </a:rPr>
+                        <a:t>YoY Growth</a:t>
+                      </a:r>
+                    </a:p>
+                  </a:txBody>
+                  <a:tcPr marL="45720" marR="45720" marT="22860" marB="22860" anchor="ctr">
+                    <a:solidFill>
+                      <a:srgbClr val="2F3C7E"/>
+                    </a:solidFill>
+                  </a:tcPr>
+                </a:tc>
+                <a:tc>
+                  <a:txBody>
+                    <a:bodyPr/>
+                    <a:lstStyle/>
+                    <a:p>
+                      <a:pPr algn="l"/>
+                      <a:r>
+                        <a:rPr lang="en-US" sz="1150" b="1" dirty="0">
+                          <a:solidFill>
+                            <a:srgbClr val="FFFFFF"/>
+                          </a:solidFill>
+                          <a:latin typeface="Calibri"/>
+                        </a:rPr>
+                        <a:t>Note</a:t>
+                      </a:r>
+                    </a:p>
+                  </a:txBody>
+                  <a:tcPr marL="45720" marR="45720" marT="22860" marB="22860" anchor="ctr">
+                    <a:solidFill>
+                      <a:srgbClr val="2F3C7E"/>
+                    </a:solidFill>
+                  </a:tcPr>
+                </a:tc>
+              </a:tr>
+              <a:tr h="411480">
+                <a:tc>
+                  <a:txBody>
+                    <a:bodyPr/>
+                    <a:lstStyle/>
+                    <a:p>
+                      <a:pPr algn="l"/>
+                      <a:r>
+                        <a:rPr lang="en-US" sz="1150" dirty="0">
+                          <a:solidFill>
+                            <a:srgbClr val="1A1A1A"/>
+                          </a:solidFill>
+                          <a:latin typeface="Calibri"/>
+                        </a:rPr>
+                        <a:t>150ml</a:t>
+                      </a:r>
+                    </a:p>
+                  </a:txBody>
+                  <a:tcPr marL="45720" marR="45720" marT="22860" marB="22860" anchor="ctr">
+                    <a:solidFill>
+                      <a:srgbClr val="FFFFFF"/>
+                    </a:solidFill>
+                  </a:tcPr>
+                </a:tc>
+                <a:tc>
+                  <a:txBody>
+                    <a:bodyPr/>
+                    <a:lstStyle/>
+                    <a:p>
+                      <a:pPr algn="l"/>
+                      <a:r>
+                        <a:rPr lang="en-US" sz="1150" dirty="0">
+                          <a:solidFill>
+                            <a:srgbClr val="1A1A1A"/>
+                          </a:solidFill>
+                          <a:latin typeface="Calibri"/>
+                        </a:rPr>
+                        <a:t>58%</a:t>
+                      </a:r>
+                    </a:p>
+                  </a:txBody>
+                  <a:tcPr marL="45720" marR="45720" marT="22860" marB="22860" anchor="ctr">
+                    <a:solidFill>
+                      <a:srgbClr val="FFFFFF"/>
+                    </a:solidFill>
+                  </a:tcPr>
+                </a:tc>
+                <a:tc>
+                  <a:txBody>
+                    <a:bodyPr/>
+                    <a:lstStyle/>
+                    <a:p>
+                      <a:pPr algn="l"/>
+                      <a:r>
+                        <a:rPr lang="en-US" sz="1150" dirty="0">
+                          <a:solidFill>
+                            <a:srgbClr val="1A1A1A"/>
+                          </a:solidFill>
+                          <a:latin typeface="Calibri"/>
+                        </a:rPr>
+                        <a:t>+98%</a:t>
+                      </a:r>
+                    </a:p>
+                  </a:txBody>
+                  <a:tcPr marL="45720" marR="45720" marT="22860" marB="22860" anchor="ctr">
+                    <a:solidFill>
+                      <a:srgbClr val="FFFFFF"/>
+                    </a:solidFill>
+                  </a:tcPr>
+                </a:tc>
+                <a:tc>
+                  <a:txBody>
+                    <a:bodyPr/>
+                    <a:lstStyle/>
+                    <a:p>
+                      <a:pPr algn="l"/>
+                      <a:r>
+                        <a:rPr lang="en-US" sz="1150" dirty="0">
+                          <a:solidFill>
+                            <a:srgbClr val="1A1A1A"/>
+                          </a:solidFill>
+                          <a:latin typeface="Calibri"/>
+                        </a:rPr>
+                        <a:t>Hero pack — protect shelf depth</a:t>
+                      </a:r>
+                    </a:p>
+                  </a:txBody>
+                  <a:tcPr marL="45720" marR="45720" marT="22860" marB="22860" anchor="ctr">
+                    <a:solidFill>
+                      <a:srgbClr val="FFFFFF"/>
+                    </a:solidFill>
+                  </a:tcPr>
+                </a:tc>
+              </a:tr>
+              <a:tr h="411480">
+                <a:tc>
+                  <a:txBody>
+                    <a:bodyPr/>
+                    <a:lstStyle/>
+                    <a:p>
+                      <a:pPr algn="l"/>
+                      <a:r>
+                        <a:rPr lang="en-US" sz="1150" dirty="0">
+                          <a:solidFill>
+                            <a:srgbClr val="1A1A1A"/>
+                          </a:solidFill>
+                          <a:latin typeface="Calibri"/>
+                        </a:rPr>
+                        <a:t>100ml</a:t>
+                      </a:r>
+                    </a:p>
+                  </a:txBody>
+                  <a:tcPr marL="45720" marR="45720" marT="22860" marB="22860" anchor="ctr">
+                    <a:solidFill>
+                      <a:srgbClr val="FFFFFF"/>
+                    </a:solidFill>
+                  </a:tcPr>
+                </a:tc>
+                <a:tc>
+                  <a:txBody>
+                    <a:bodyPr/>
+                    <a:lstStyle/>
+                    <a:p>
+                      <a:pPr algn="l"/>
+                      <a:r>
+                        <a:rPr lang="en-US" sz="1150" dirty="0">
+                          <a:solidFill>
+                            <a:srgbClr val="1A1A1A"/>
+                          </a:solidFill>
+                          <a:latin typeface="Calibri"/>
+                        </a:rPr>
+                        <a:t>21%</a:t>
+                      </a:r>
+                    </a:p>
+                  </a:txBody>
+                  <a:tcPr marL="45720" marR="45720" marT="22860" marB="22860" anchor="ctr">
+                    <a:solidFill>
+                      <a:srgbClr val="FFFFFF"/>
+                    </a:solidFill>
+                  </a:tcPr>
+                </a:tc>
+                <a:tc>
+                  <a:txBody>
+                    <a:bodyPr/>
+                    <a:lstStyle/>
+                    <a:p>
+                      <a:pPr algn="l"/>
+                      <a:r>
+                        <a:rPr lang="en-US" sz="1150" dirty="0">
+                          <a:solidFill>
+                            <a:srgbClr val="1A1A1A"/>
+                          </a:solidFill>
+                          <a:latin typeface="Calibri"/>
+                        </a:rPr>
+                        <a:t>-11%</a:t>
+                      </a:r>
+                    </a:p>
+                  </a:txBody>
+                  <a:tcPr marL="45720" marR="45720" marT="22860" marB="22860" anchor="ctr">
+                    <a:solidFill>
+                      <a:srgbClr val="FFFFFF"/>
+                    </a:solidFill>
+                  </a:tcPr>
+                </a:tc>
+                <a:tc>
+                  <a:txBody>
+                    <a:bodyPr/>
+                    <a:lstStyle/>
+                    <a:p>
+                      <a:pPr algn="l"/>
+                      <a:r>
+                        <a:rPr lang="en-US" sz="1150" dirty="0">
+                          <a:solidFill>
+                            <a:srgbClr val="1A1A1A"/>
+                          </a:solidFill>
+                          <a:latin typeface="Calibri"/>
+                        </a:rPr>
+                        <a:t>Declining — check availability/promo</a:t>
+                      </a:r>
+                    </a:p>
+                  </a:txBody>
+                  <a:tcPr marL="45720" marR="45720" marT="22860" marB="22860" anchor="ctr">
+                    <a:solidFill>
+                      <a:srgbClr val="FFFFFF"/>
+                    </a:solidFill>
+                  </a:tcPr>
+                </a:tc>
+              </a:tr>
+              <a:tr h="411480">
+                <a:tc>
+                  <a:txBody>
+                    <a:bodyPr/>
+                    <a:lstStyle/>
+                    <a:p>
+                      <a:pPr algn="l"/>
+                      <a:r>
+                        <a:rPr lang="en-US" sz="1150" dirty="0">
+                          <a:solidFill>
+                            <a:srgbClr val="1A1A1A"/>
+                          </a:solidFill>
+                          <a:latin typeface="Calibri"/>
+                        </a:rPr>
+                        <a:t>200ml</a:t>
+                      </a:r>
+                    </a:p>
+                  </a:txBody>
+                  <a:tcPr marL="45720" marR="45720" marT="22860" marB="22860" anchor="ctr">
+                    <a:solidFill>
+                      <a:srgbClr val="FFFFFF"/>
+                    </a:solidFill>
+                  </a:tcPr>
+                </a:tc>
+                <a:tc>
+                  <a:txBody>
+                    <a:bodyPr/>
+                    <a:lstStyle/>
+                    <a:p>
+                      <a:pPr algn="l"/>
+                      <a:r>
+                        <a:rPr lang="en-US" sz="1150" dirty="0">
+                          <a:solidFill>
+                            <a:srgbClr val="1A1A1A"/>
+                          </a:solidFill>
+                          <a:latin typeface="Calibri"/>
+                        </a:rPr>
+                        <a:t>11%</a:t>
+                      </a:r>
+                    </a:p>
+                  </a:txBody>
+                  <a:tcPr marL="45720" marR="45720" marT="22860" marB="22860" anchor="ctr">
+                    <a:solidFill>
+                      <a:srgbClr val="FFFFFF"/>
+                    </a:solidFill>
+                  </a:tcPr>
+                </a:tc>
+                <a:tc>
+                  <a:txBody>
+                    <a:bodyPr/>
+                    <a:lstStyle/>
+                    <a:p>
+                      <a:pPr algn="l"/>
+                      <a:r>
+                        <a:rPr lang="en-US" sz="1150" dirty="0">
+                          <a:solidFill>
+                            <a:srgbClr val="1A1A1A"/>
+                          </a:solidFill>
+                          <a:latin typeface="Calibri"/>
+                        </a:rPr>
+                        <a:t>n/a</a:t>
+                      </a:r>
+                    </a:p>
+                  </a:txBody>
+                  <a:tcPr marL="45720" marR="45720" marT="22860" marB="22860" anchor="ctr">
+                    <a:solidFill>
+                      <a:srgbClr val="FFFFFF"/>
+                    </a:solidFill>
+                  </a:tcPr>
+                </a:tc>
+                <a:tc>
+                  <a:txBody>
+                    <a:bodyPr/>
+                    <a:lstStyle/>
+                    <a:p>
+                      <a:pPr algn="l"/>
+                      <a:r>
+                        <a:rPr lang="en-US" sz="1150" dirty="0">
+                          <a:solidFill>
+                            <a:srgbClr val="1A1A1A"/>
+                          </a:solidFill>
+                          <a:latin typeface="Calibri"/>
+                        </a:rPr>
+                        <a:t>Emerging growth builder</a:t>
+                      </a:r>
+                    </a:p>
+                  </a:txBody>
+                  <a:tcPr marL="45720" marR="45720" marT="22860" marB="22860" anchor="ctr">
+                    <a:solidFill>
+                      <a:srgbClr val="FFFFFF"/>
+                    </a:solidFill>
+                  </a:tcPr>
+                </a:tc>
+              </a:tr>
+              <a:tr h="411480">
+                <a:tc>
+                  <a:txBody>
+                    <a:bodyPr/>
+                    <a:lstStyle/>
+                    <a:p>
+                      <a:pPr algn="l"/>
+                      <a:r>
+                        <a:rPr lang="en-US" sz="1150" dirty="0">
+                          <a:solidFill>
+                            <a:srgbClr val="1A1A1A"/>
+                          </a:solidFill>
+                          <a:latin typeface="Calibri"/>
+                        </a:rPr>
+                        <a:t>50ml</a:t>
+                      </a:r>
+                    </a:p>
+                  </a:txBody>
+                  <a:tcPr marL="45720" marR="45720" marT="22860" marB="22860" anchor="ctr">
+                    <a:solidFill>
+                      <a:srgbClr val="FFFFFF"/>
+                    </a:solidFill>
+                  </a:tcPr>
+                </a:tc>
+                <a:tc>
+                  <a:txBody>
+                    <a:bodyPr/>
+                    <a:lstStyle/>
+                    <a:p>
+                      <a:pPr algn="l"/>
+                      <a:r>
+                        <a:rPr lang="en-US" sz="1150" dirty="0">
+                          <a:solidFill>
+                            <a:srgbClr val="1A1A1A"/>
+                          </a:solidFill>
+                          <a:latin typeface="Calibri"/>
+                        </a:rPr>
+                        <a:t>11%</a:t>
+                      </a:r>
+                    </a:p>
+                  </a:txBody>
+                  <a:tcPr marL="45720" marR="45720" marT="22860" marB="22860" anchor="ctr">
+                    <a:solidFill>
+                      <a:srgbClr val="FFFFFF"/>
+                    </a:solidFill>
+                  </a:tcPr>
+                </a:tc>
+                <a:tc>
+                  <a:txBody>
+                    <a:bodyPr/>
+                    <a:lstStyle/>
+                    <a:p>
+                      <a:pPr algn="l"/>
+                      <a:r>
+                        <a:rPr lang="en-US" sz="1150" dirty="0">
+                          <a:solidFill>
+                            <a:srgbClr val="1A1A1A"/>
+                          </a:solidFill>
+                          <a:latin typeface="Calibri"/>
+                        </a:rPr>
+                        <a:t>+80%</a:t>
+                      </a:r>
+                    </a:p>
+                  </a:txBody>
+                  <a:tcPr marL="45720" marR="45720" marT="22860" marB="22860" anchor="ctr">
+                    <a:solidFill>
+                      <a:srgbClr val="FFFFFF"/>
+                    </a:solidFill>
+                  </a:tcPr>
+                </a:tc>
+                <a:tc>
+                  <a:txBody>
+                    <a:bodyPr/>
+                    <a:lstStyle/>
+                    <a:p>
+                      <a:pPr algn="l"/>
+                      <a:r>
+                        <a:rPr lang="en-US" sz="1150" dirty="0">
+                          <a:solidFill>
+                            <a:srgbClr val="1A1A1A"/>
+                          </a:solidFill>
+                          <a:latin typeface="Calibri"/>
+                        </a:rPr>
+                        <a:t>Trial pack — till-point placement</a:t>
+                      </a:r>
+                    </a:p>
+                  </a:txBody>
+                  <a:tcPr marL="45720" marR="45720" marT="22860" marB="22860" anchor="ctr">
+                    <a:solidFill>
+                      <a:srgbClr val="FFFFFF"/>
+                    </a:solidFill>
+                  </a:tcPr>
+                </a:tc>
+              </a:tr>
+              <a:tr h="411480">
+                <a:tc>
+                  <a:txBody>
+                    <a:bodyPr/>
+                    <a:lstStyle/>
+                    <a:p>
+                      <a:pPr algn="l"/>
+                      <a:r>
+                        <a:rPr lang="en-US" sz="1150" dirty="0">
+                          <a:solidFill>
+                            <a:srgbClr val="1A1A1A"/>
+                          </a:solidFill>
+                          <a:latin typeface="Calibri"/>
+                        </a:rPr>
+                        <a:t>250ml</a:t>
+                      </a:r>
+                    </a:p>
+                  </a:txBody>
+                  <a:tcPr marL="45720" marR="45720" marT="22860" marB="22860" anchor="ctr">
+                    <a:solidFill>
+                      <a:srgbClr val="FFFFFF"/>
+                    </a:solidFill>
+                  </a:tcPr>
+                </a:tc>
+                <a:tc>
+                  <a:txBody>
+                    <a:bodyPr/>
+                    <a:lstStyle/>
+                    <a:p>
+                      <a:pPr algn="l"/>
+                      <a:r>
+                        <a:rPr lang="en-US" sz="1150" dirty="0">
+                          <a:solidFill>
+                            <a:srgbClr val="1A1A1A"/>
+                          </a:solidFill>
+                          <a:latin typeface="Calibri"/>
+                        </a:rPr>
+                        <a:t>0%</a:t>
+                      </a:r>
+                    </a:p>
+                  </a:txBody>
+                  <a:tcPr marL="45720" marR="45720" marT="22860" marB="22860" anchor="ctr">
+                    <a:solidFill>
+                      <a:srgbClr val="FFFFFF"/>
+                    </a:solidFill>
+                  </a:tcPr>
+                </a:tc>
+                <a:tc>
+                  <a:txBody>
+                    <a:bodyPr/>
+                    <a:lstStyle/>
+                    <a:p>
+                      <a:pPr algn="l"/>
+                      <a:r>
+                        <a:rPr lang="en-US" sz="1150" dirty="0">
+                          <a:solidFill>
+                            <a:srgbClr val="1A1A1A"/>
+                          </a:solidFill>
+                          <a:latin typeface="Calibri"/>
+                        </a:rPr>
+                        <a:t>-94%</a:t>
+                      </a:r>
+                    </a:p>
+                  </a:txBody>
+                  <a:tcPr marL="45720" marR="45720" marT="22860" marB="22860" anchor="ctr">
+                    <a:solidFill>
+                      <a:srgbClr val="FFFFFF"/>
+                    </a:solidFill>
+                  </a:tcPr>
+                </a:tc>
+                <a:tc>
+                  <a:txBody>
+                    <a:bodyPr/>
+                    <a:lstStyle/>
+                    <a:p>
+                      <a:pPr algn="l"/>
+                      <a:r>
+                        <a:rPr lang="en-US" sz="1150" dirty="0">
+                          <a:solidFill>
+                            <a:srgbClr val="1A1A1A"/>
+                          </a:solidFill>
+                          <a:latin typeface="Calibri"/>
+                        </a:rPr>
+                        <a:t>Sharp decline, low base</a:t>
+                      </a:r>
+                    </a:p>
+                  </a:txBody>
+                  <a:tcPr marL="45720" marR="45720" marT="22860" marB="22860" anchor="ctr">
+                    <a:solidFill>
+                      <a:srgbClr val="FFFFFF"/>
+                    </a:solidFill>
+                  </a:tcPr>
+                </a:tc>
+              </a:tr>
+            </a:tbl>
+          </a:graphicData>
+        </a:graphic>
+      </p:graphicFrame>
+      <p:sp>
+        <p:nvSpPr>
+          <p:cNvPr id="5" name="TextBox 5"/>
+          <p:cNvSpPr txBox="1"/>
+          <p:nvPr/>
+        </p:nvSpPr>
+        <p:spPr>
+          <a:xfrm>
+            <a:off x="548640" y="3703320"/>
+            <a:ext cx="5486400" cy="320040"/>
+          </a:xfrm>
+          <a:prstGeom prst="rect">
+            <a:avLst/>
+          </a:prstGeom>
+          <a:noFill/>
+        </p:spPr>
+        <p:txBody>
+          <a:bodyPr wrap="square" anchor="t" lIns="0" tIns="0" rIns="0" bIns="0">
+            <a:noAutofit/>
+          </a:bodyPr>
+          <a:lstStyle/>
+          <a:p>
+            <a:pPr algn="l"/>
+            <a:r>
+              <a:rPr lang="en-US" sz="1400" b="1" dirty="0">
+                <a:solidFill>
+                  <a:srgbClr val="6D2E46"/>
+                </a:solidFill>
+                <a:latin typeface="Calibri"/>
+              </a:rPr>
+              <a:t>High-contribution, low-share states</a:t>
+            </a:r>
+          </a:p>
+        </p:txBody>
+      </p:sp>
+      <p:graphicFrame>
+        <p:nvGraphicFramePr>
+          <p:cNvPr id="6" name="Table 6"/>
+          <p:cNvGraphicFramePr>
+            <a:graphicFrameLocks noGrp="1"/>
+          </p:cNvGraphicFramePr>
+          <p:nvPr/>
+        </p:nvGraphicFramePr>
+        <p:xfrm>
+          <a:off x="548640" y="4069080"/>
+          <a:ext cx="11064240" cy="1920240"/>
+        </p:xfrm>
+        <a:graphic>
+          <a:graphicData uri="http://schemas.openxmlformats.org/drawingml/2006/table">
+            <a:tbl>
+              <a:tblPr firstRow="1" bandRow="0">
+                <a:tableStyleId>{5C22544A-7EE6-4342-B048-85BDC9FD1C3A}</a:tableStyleId>
+              </a:tblPr>
+              <a:tblGrid>
+                <a:gridCol w="3657600"/>
+                <a:gridCol w="2468880"/>
+                <a:gridCol w="2011680"/>
+                <a:gridCol w="2926080"/>
+              </a:tblGrid>
+              <a:tr h="384048">
+                <a:tc>
+                  <a:txBody>
+                    <a:bodyPr/>
+                    <a:lstStyle/>
+                    <a:p>
+                      <a:pPr algn="l"/>
+                      <a:r>
+                        <a:rPr lang="en-US" sz="1150" b="1" dirty="0">
+                          <a:solidFill>
+                            <a:srgbClr val="FFFFFF"/>
+                          </a:solidFill>
+                          <a:latin typeface="Calibri"/>
+                        </a:rPr>
+                        <a:t>State</a:t>
+                      </a:r>
+                    </a:p>
+                  </a:txBody>
+                  <a:tcPr marL="45720" marR="45720" marT="22860" marB="22860" anchor="ctr">
+                    <a:solidFill>
+                      <a:srgbClr val="2F3C7E"/>
+                    </a:solidFill>
+                  </a:tcPr>
+                </a:tc>
+                <a:tc>
+                  <a:txBody>
+                    <a:bodyPr/>
+                    <a:lstStyle/>
+                    <a:p>
+                      <a:pPr algn="l"/>
+                      <a:r>
+                        <a:rPr lang="en-US" sz="1150" b="1" dirty="0">
+                          <a:solidFill>
+                            <a:srgbClr val="FFFFFF"/>
+                          </a:solidFill>
+                          <a:latin typeface="Calibri"/>
+                        </a:rPr>
+                        <a:t>Category Contribution</a:t>
+                      </a:r>
+                    </a:p>
+                  </a:txBody>
+                  <a:tcPr marL="45720" marR="45720" marT="22860" marB="22860" anchor="ctr">
+                    <a:solidFill>
+                      <a:srgbClr val="2F3C7E"/>
+                    </a:solidFill>
+                  </a:tcPr>
+                </a:tc>
+                <a:tc>
+                  <a:txBody>
+                    <a:bodyPr/>
+                    <a:lstStyle/>
+                    <a:p>
+                      <a:pPr algn="l"/>
+                      <a:r>
+                        <a:rPr lang="en-US" sz="1150" b="1" dirty="0">
+                          <a:solidFill>
+                            <a:srgbClr val="FFFFFF"/>
+                          </a:solidFill>
+                          <a:latin typeface="Calibri"/>
+                        </a:rPr>
+                        <a:t>May'26 Share</a:t>
+                      </a:r>
+                    </a:p>
+                  </a:txBody>
+                  <a:tcPr marL="45720" marR="45720" marT="22860" marB="22860" anchor="ctr">
+                    <a:solidFill>
+                      <a:srgbClr val="2F3C7E"/>
+                    </a:solidFill>
+                  </a:tcPr>
+                </a:tc>
+                <a:tc>
+                  <a:txBody>
+                    <a:bodyPr/>
+                    <a:lstStyle/>
+                    <a:p>
+                      <a:pPr algn="l"/>
+                      <a:r>
+                        <a:rPr lang="en-US" sz="1150" b="1" dirty="0">
+                          <a:solidFill>
+                            <a:srgbClr val="FFFFFF"/>
+                          </a:solidFill>
+                          <a:latin typeface="Calibri"/>
+                        </a:rPr>
+                        <a:t>Gap Read</a:t>
+                      </a:r>
+                    </a:p>
+                  </a:txBody>
+                  <a:tcPr marL="45720" marR="45720" marT="22860" marB="22860" anchor="ctr">
+                    <a:solidFill>
+                      <a:srgbClr val="2F3C7E"/>
+                    </a:solidFill>
+                  </a:tcPr>
+                </a:tc>
+              </a:tr>
+              <a:tr h="384048">
+                <a:tc>
+                  <a:txBody>
+                    <a:bodyPr/>
+                    <a:lstStyle/>
+                    <a:p>
+                      <a:pPr algn="l"/>
+                      <a:r>
+                        <a:rPr lang="en-US" sz="1150" dirty="0">
+                          <a:solidFill>
+                            <a:srgbClr val="1A1A1A"/>
+                          </a:solidFill>
+                          <a:latin typeface="Calibri"/>
+                        </a:rPr>
+                        <a:t>Uttar Pradesh (Facewash)</a:t>
+                      </a:r>
+                    </a:p>
+                  </a:txBody>
+                  <a:tcPr marL="45720" marR="45720" marT="22860" marB="22860" anchor="ctr">
+                    <a:solidFill>
+                      <a:srgbClr val="FFFFFF"/>
+                    </a:solidFill>
+                  </a:tcPr>
+                </a:tc>
+                <a:tc>
+                  <a:txBody>
+                    <a:bodyPr/>
+                    <a:lstStyle/>
+                    <a:p>
+                      <a:pPr algn="l"/>
+                      <a:r>
+                        <a:rPr lang="en-US" sz="1150" dirty="0">
+                          <a:solidFill>
+                            <a:srgbClr val="1A1A1A"/>
+                          </a:solidFill>
+                          <a:latin typeface="Calibri"/>
+                        </a:rPr>
+                        <a:t>15%</a:t>
+                      </a:r>
+                    </a:p>
+                  </a:txBody>
+                  <a:tcPr marL="45720" marR="45720" marT="22860" marB="22860" anchor="ctr">
+                    <a:solidFill>
+                      <a:srgbClr val="FFFFFF"/>
+                    </a:solidFill>
+                  </a:tcPr>
+                </a:tc>
+                <a:tc>
+                  <a:txBody>
+                    <a:bodyPr/>
+                    <a:lstStyle/>
+                    <a:p>
+                      <a:pPr algn="l"/>
+                      <a:r>
+                        <a:rPr lang="en-US" sz="1150" dirty="0">
+                          <a:solidFill>
+                            <a:srgbClr val="1A1A1A"/>
+                          </a:solidFill>
+                          <a:latin typeface="Calibri"/>
+                        </a:rPr>
+                        <a:t>6%</a:t>
+                      </a:r>
+                    </a:p>
+                  </a:txBody>
+                  <a:tcPr marL="45720" marR="45720" marT="22860" marB="22860" anchor="ctr">
+                    <a:solidFill>
+                      <a:srgbClr val="FFFFFF"/>
+                    </a:solidFill>
+                  </a:tcPr>
+                </a:tc>
+                <a:tc>
+                  <a:txBody>
+                    <a:bodyPr/>
+                    <a:lstStyle/>
+                    <a:p>
+                      <a:pPr algn="l"/>
+                      <a:r>
+                        <a:rPr lang="en-US" sz="1150" dirty="0">
+                          <a:solidFill>
+                            <a:srgbClr val="1A1A1A"/>
+                          </a:solidFill>
+                          <a:latin typeface="Calibri"/>
+                        </a:rPr>
+                        <a:t>Under-penetrated</a:t>
+                      </a:r>
+                    </a:p>
+                  </a:txBody>
+                  <a:tcPr marL="45720" marR="45720" marT="22860" marB="22860" anchor="ctr">
+                    <a:solidFill>
+                      <a:srgbClr val="FFFFFF"/>
+                    </a:solidFill>
+                  </a:tcPr>
+                </a:tc>
+              </a:tr>
+              <a:tr h="384048">
+                <a:tc>
+                  <a:txBody>
+                    <a:bodyPr/>
+                    <a:lstStyle/>
+                    <a:p>
+                      <a:pPr algn="l"/>
+                      <a:r>
+                        <a:rPr lang="en-US" sz="1150" dirty="0">
+                          <a:solidFill>
+                            <a:srgbClr val="1A1A1A"/>
+                          </a:solidFill>
+                          <a:latin typeface="Calibri"/>
+                        </a:rPr>
+                        <a:t>Maharashtra (Facewash)</a:t>
+                      </a:r>
+                    </a:p>
+                  </a:txBody>
+                  <a:tcPr marL="45720" marR="45720" marT="22860" marB="22860" anchor="ctr">
+                    <a:solidFill>
+                      <a:srgbClr val="FFFFFF"/>
+                    </a:solidFill>
+                  </a:tcPr>
+                </a:tc>
+                <a:tc>
+                  <a:txBody>
+                    <a:bodyPr/>
+                    <a:lstStyle/>
+                    <a:p>
+                      <a:pPr algn="l"/>
+                      <a:r>
+                        <a:rPr lang="en-US" sz="1150" dirty="0">
+                          <a:solidFill>
+                            <a:srgbClr val="1A1A1A"/>
+                          </a:solidFill>
+                          <a:latin typeface="Calibri"/>
+                        </a:rPr>
+                        <a:t>14%</a:t>
+                      </a:r>
+                    </a:p>
+                  </a:txBody>
+                  <a:tcPr marL="45720" marR="45720" marT="22860" marB="22860" anchor="ctr">
+                    <a:solidFill>
+                      <a:srgbClr val="FFFFFF"/>
+                    </a:solidFill>
+                  </a:tcPr>
+                </a:tc>
+                <a:tc>
+                  <a:txBody>
+                    <a:bodyPr/>
+                    <a:lstStyle/>
+                    <a:p>
+                      <a:pPr algn="l"/>
+                      <a:r>
+                        <a:rPr lang="en-US" sz="1150" dirty="0">
+                          <a:solidFill>
+                            <a:srgbClr val="1A1A1A"/>
+                          </a:solidFill>
+                          <a:latin typeface="Calibri"/>
+                        </a:rPr>
+                        <a:t>6%</a:t>
+                      </a:r>
+                    </a:p>
+                  </a:txBody>
+                  <a:tcPr marL="45720" marR="45720" marT="22860" marB="22860" anchor="ctr">
+                    <a:solidFill>
+                      <a:srgbClr val="FFFFFF"/>
+                    </a:solidFill>
+                  </a:tcPr>
+                </a:tc>
+                <a:tc>
+                  <a:txBody>
+                    <a:bodyPr/>
+                    <a:lstStyle/>
+                    <a:p>
+                      <a:pPr algn="l"/>
+                      <a:r>
+                        <a:rPr lang="en-US" sz="1150" dirty="0">
+                          <a:solidFill>
+                            <a:srgbClr val="1A1A1A"/>
+                          </a:solidFill>
+                          <a:latin typeface="Calibri"/>
+                        </a:rPr>
+                        <a:t>Under-penetrated</a:t>
+                      </a:r>
+                    </a:p>
+                  </a:txBody>
+                  <a:tcPr marL="45720" marR="45720" marT="22860" marB="22860" anchor="ctr">
+                    <a:solidFill>
+                      <a:srgbClr val="FFFFFF"/>
+                    </a:solidFill>
+                  </a:tcPr>
+                </a:tc>
+              </a:tr>
+              <a:tr h="384048">
+                <a:tc>
+                  <a:txBody>
+                    <a:bodyPr/>
+                    <a:lstStyle/>
+                    <a:p>
+                      <a:pPr algn="l"/>
+                      <a:r>
+                        <a:rPr lang="en-US" sz="1150" dirty="0">
+                          <a:solidFill>
+                            <a:srgbClr val="1A1A1A"/>
+                          </a:solidFill>
+                          <a:latin typeface="Calibri"/>
+                        </a:rPr>
+                        <a:t>Maharashtra (Shampoo)</a:t>
+                      </a:r>
+                    </a:p>
+                  </a:txBody>
+                  <a:tcPr marL="45720" marR="45720" marT="22860" marB="22860" anchor="ctr">
+                    <a:solidFill>
+                      <a:srgbClr val="FFFFFF"/>
+                    </a:solidFill>
+                  </a:tcPr>
+                </a:tc>
+                <a:tc>
+                  <a:txBody>
+                    <a:bodyPr/>
+                    <a:lstStyle/>
+                    <a:p>
+                      <a:pPr algn="l"/>
+                      <a:r>
+                        <a:rPr lang="en-US" sz="1150" dirty="0">
+                          <a:solidFill>
+                            <a:srgbClr val="1A1A1A"/>
+                          </a:solidFill>
+                          <a:latin typeface="Calibri"/>
+                        </a:rPr>
+                        <a:t>15%</a:t>
+                      </a:r>
+                    </a:p>
+                  </a:txBody>
+                  <a:tcPr marL="45720" marR="45720" marT="22860" marB="22860" anchor="ctr">
+                    <a:solidFill>
+                      <a:srgbClr val="FFFFFF"/>
+                    </a:solidFill>
+                  </a:tcPr>
+                </a:tc>
+                <a:tc>
+                  <a:txBody>
+                    <a:bodyPr/>
+                    <a:lstStyle/>
+                    <a:p>
+                      <a:pPr algn="l"/>
+                      <a:r>
+                        <a:rPr lang="en-US" sz="1150" dirty="0">
+                          <a:solidFill>
+                            <a:srgbClr val="1A1A1A"/>
+                          </a:solidFill>
+                          <a:latin typeface="Calibri"/>
+                        </a:rPr>
+                        <a:t>1%</a:t>
+                      </a:r>
+                    </a:p>
+                  </a:txBody>
+                  <a:tcPr marL="45720" marR="45720" marT="22860" marB="22860" anchor="ctr">
+                    <a:solidFill>
+                      <a:srgbClr val="FFFFFF"/>
+                    </a:solidFill>
+                  </a:tcPr>
+                </a:tc>
+                <a:tc>
+                  <a:txBody>
+                    <a:bodyPr/>
+                    <a:lstStyle/>
+                    <a:p>
+                      <a:pPr algn="l"/>
+                      <a:r>
+                        <a:rPr lang="en-US" sz="1150" dirty="0">
+                          <a:solidFill>
+                            <a:srgbClr val="1A1A1A"/>
+                          </a:solidFill>
+                          <a:latin typeface="Calibri"/>
+                        </a:rPr>
+                        <a:t>Under-penetrated</a:t>
+                      </a:r>
+                    </a:p>
+                  </a:txBody>
+                  <a:tcPr marL="45720" marR="45720" marT="22860" marB="22860" anchor="ctr">
+                    <a:solidFill>
+                      <a:srgbClr val="FFFFFF"/>
+                    </a:solidFill>
+                  </a:tcPr>
+                </a:tc>
+              </a:tr>
+              <a:tr h="384048">
+                <a:tc>
+                  <a:txBody>
+                    <a:bodyPr/>
+                    <a:lstStyle/>
+                    <a:p>
+                      <a:pPr algn="l"/>
+                      <a:r>
+                        <a:rPr lang="en-US" sz="1150" dirty="0">
+                          <a:solidFill>
+                            <a:srgbClr val="1A1A1A"/>
+                          </a:solidFill>
+                          <a:latin typeface="Calibri"/>
+                        </a:rPr>
+                        <a:t>Uttar Pradesh (Shampoo)</a:t>
+                      </a:r>
+                    </a:p>
+                  </a:txBody>
+                  <a:tcPr marL="45720" marR="45720" marT="22860" marB="22860" anchor="ctr">
+                    <a:solidFill>
+                      <a:srgbClr val="FFFFFF"/>
+                    </a:solidFill>
+                  </a:tcPr>
+                </a:tc>
+                <a:tc>
+                  <a:txBody>
+                    <a:bodyPr/>
+                    <a:lstStyle/>
+                    <a:p>
+                      <a:pPr algn="l"/>
+                      <a:r>
+                        <a:rPr lang="en-US" sz="1150" dirty="0">
+                          <a:solidFill>
+                            <a:srgbClr val="1A1A1A"/>
+                          </a:solidFill>
+                          <a:latin typeface="Calibri"/>
+                        </a:rPr>
+                        <a:t>10%</a:t>
+                      </a:r>
+                    </a:p>
+                  </a:txBody>
+                  <a:tcPr marL="45720" marR="45720" marT="22860" marB="22860" anchor="ctr">
+                    <a:solidFill>
+                      <a:srgbClr val="FFFFFF"/>
+                    </a:solidFill>
+                  </a:tcPr>
+                </a:tc>
+                <a:tc>
+                  <a:txBody>
+                    <a:bodyPr/>
+                    <a:lstStyle/>
+                    <a:p>
+                      <a:pPr algn="l"/>
+                      <a:r>
+                        <a:rPr lang="en-US" sz="1150" dirty="0">
+                          <a:solidFill>
+                            <a:srgbClr val="1A1A1A"/>
+                          </a:solidFill>
+                          <a:latin typeface="Calibri"/>
+                        </a:rPr>
+                        <a:t>2%</a:t>
+                      </a:r>
+                    </a:p>
+                  </a:txBody>
+                  <a:tcPr marL="45720" marR="45720" marT="22860" marB="22860" anchor="ctr">
+                    <a:solidFill>
+                      <a:srgbClr val="FFFFFF"/>
+                    </a:solidFill>
+                  </a:tcPr>
+                </a:tc>
+                <a:tc>
+                  <a:txBody>
+                    <a:bodyPr/>
+                    <a:lstStyle/>
+                    <a:p>
+                      <a:pPr algn="l"/>
+                      <a:r>
+                        <a:rPr lang="en-US" sz="1150" dirty="0">
+                          <a:solidFill>
+                            <a:srgbClr val="1A1A1A"/>
+                          </a:solidFill>
+                          <a:latin typeface="Calibri"/>
+                        </a:rPr>
+                        <a:t>Under-penetrated</a:t>
+                      </a:r>
+                    </a:p>
+                  </a:txBody>
+                  <a:tcPr marL="45720" marR="45720" marT="22860" marB="22860" anchor="ctr">
+                    <a:solidFill>
+                      <a:srgbClr val="FFFFFF"/>
+                    </a:solidFill>
+                  </a:tcPr>
+                </a:tc>
+              </a:tr>
+            </a:tbl>
+          </a:graphicData>
+        </a:graphic>
+      </p:graphicFrame>
+      <p:sp>
+        <p:nvSpPr>
+          <p:cNvPr id="7" name="Rect 7"/>
+          <p:cNvSpPr/>
+          <p:nvPr/>
+        </p:nvSpPr>
+        <p:spPr>
+          <a:xfrm>
+            <a:off x="548640" y="5806440"/>
+            <a:ext cx="11064240" cy="777240"/>
+          </a:xfrm>
+          <a:prstGeom prst="roundRect">
+            <a:avLst/>
+          </a:prstGeom>
+          <a:solidFill>
+            <a:srgbClr val="2F3C7E"/>
+          </a:solidFill>
+          <a:ln>
+            <a:noFill/>
+          </a:ln>
+          <a:effectLst/>
+        </p:spPr>
+        <p:txBody>
+          <a:bodyPr/>
+          <a:lstStyle/>
+          <a:p/>
+        </p:txBody>
+      </p:sp>
+      <p:sp>
+        <p:nvSpPr>
+          <p:cNvPr id="8" name="TextBox 8"/>
+          <p:cNvSpPr txBox="1"/>
+          <p:nvPr/>
+        </p:nvSpPr>
+        <p:spPr>
+          <a:xfrm>
+            <a:off x="822960" y="5943600"/>
+            <a:ext cx="10515600" cy="548640"/>
+          </a:xfrm>
+          <a:prstGeom prst="rect">
+            <a:avLst/>
+          </a:prstGeom>
+          <a:noFill/>
+        </p:spPr>
+        <p:txBody>
+          <a:bodyPr wrap="square" anchor="t" lIns="0" tIns="0" rIns="0" bIns="0">
+            <a:noAutofit/>
+          </a:bodyPr>
+          <a:lstStyle/>
+          <a:p>
+            <a:pPr algn="l"/>
+            <a:r>
+              <a:rPr lang="en-US" sz="1300" b="1" dirty="0">
+                <a:solidFill>
+                  <a:srgbClr val="FFFFFF"/>
+                </a:solidFill>
+                <a:latin typeface="Calibri"/>
+              </a:rPr>
+              <a:t>Key insight: Uttar Pradesh and Maharashtra are the two largest under-penetrated states across BOTH Facewash and Shampoo — the single biggest distribution/visibility white space.</a:t>
+            </a:r>
+          </a:p>
+        </p:txBody>
+      </p:sp>
+    </p:spTree>
+  </p:cSld>
+  <p:clrMapOvr>
+    <a:masterClrMapping/>
+  </p:clrMapOvr>
+</p:sld>
+</file>
+
+<file path=ppt/slides/slide8.xml><?xml version="1.0" encoding="utf-8"?>
+<p:sld xmlns:a="http://schemas.openxmlformats.org/drawingml/2006/main" xmlns:r="http://schemas.openxmlformats.org/officeDocument/2006/relationships" xmlns:p="http://schemas.openxmlformats.org/presentationml/2006/main">
+  <p:cSld>
+    <p:bg>
+      <p:bgPr>
+        <a:solidFill>
+          <a:srgbClr val="FFFFFF"/>
+        </a:solidFill>
+        <a:effectLst/>
+      </p:bgPr>
+    </p:bg>
+    <p:spTree>
+      <p:nvGrpSpPr>
+        <p:cNvPr id="1" name=""/>
+        <p:cNvGrpSpPr/>
+        <p:nvPr/>
+      </p:nvGrpSpPr>
+      <p:grpSpPr>
+        <a:xfrm>
+          <a:off x="0" y="0"/>
+          <a:ext cx="0" cy="0"/>
+          <a:chOff x="0" y="0"/>
+          <a:chExt cx="0" cy="0"/>
+        </a:xfrm>
+      </p:grpSpPr>
+      <p:sp>
+        <p:nvSpPr>
+          <p:cNvPr id="2" name="TextBox 2"/>
+          <p:cNvSpPr txBox="1"/>
+          <p:nvPr/>
+        </p:nvSpPr>
+        <p:spPr>
+          <a:xfrm>
             <a:off x="548640" y="365760"/>
             <a:ext cx="10972800" cy="548640"/>
           </a:xfrm>
@@ -3625,7 +6763,7 @@
         </p:nvGraphicFramePr>
         <p:xfrm>
           <a:off x="548640" y="1097280"/>
-          <a:ext cx="11064240" cy="3566160"/>
+          <a:ext cx="11064240" cy="3968496"/>
         </p:xfrm>
         <a:graphic>
           <a:graphicData uri="http://schemas.openxmlformats.org/drawingml/2006/table">
@@ -3639,15 +6777,15 @@
                 <a:gridCol w="1645920"/>
                 <a:gridCol w="1645920"/>
               </a:tblGrid>
-              <a:tr h="594360">
-                <a:tc>
-                  <a:txBody>
-                    <a:bodyPr/>
-                    <a:lstStyle/>
-                    <a:p>
-                      <a:pPr algn="l"/>
-                      <a:r>
-                        <a:rPr lang="en-US" sz="1200" b="1" dirty="0">
+              <a:tr h="566928">
+                <a:tc>
+                  <a:txBody>
+                    <a:bodyPr/>
+                    <a:lstStyle/>
+                    <a:p>
+                      <a:pPr algn="l"/>
+                      <a:r>
+                        <a:rPr lang="en-US" sz="1150" b="1" dirty="0">
                           <a:solidFill>
                             <a:srgbClr val="FFFFFF"/>
                           </a:solidFill>
@@ -3670,7 +6808,7 @@
                     <a:p>
                       <a:pPr algn="l"/>
                       <a:r>
-                        <a:rPr lang="en-US" sz="1200" b="1" dirty="0">
+                        <a:rPr lang="en-US" sz="1150" b="1" dirty="0">
                           <a:solidFill>
                             <a:srgbClr val="FFFFFF"/>
                           </a:solidFill>
@@ -3693,7 +6831,7 @@
                     <a:p>
                       <a:pPr algn="l"/>
                       <a:r>
-                        <a:rPr lang="en-US" sz="1200" b="1" dirty="0">
+                        <a:rPr lang="en-US" sz="1150" b="1" dirty="0">
                           <a:solidFill>
                             <a:srgbClr val="FFFFFF"/>
                           </a:solidFill>
@@ -3716,7 +6854,7 @@
                     <a:p>
                       <a:pPr algn="l"/>
                       <a:r>
-                        <a:rPr lang="en-US" sz="1200" b="1" dirty="0">
+                        <a:rPr lang="en-US" sz="1150" b="1" dirty="0">
                           <a:solidFill>
                             <a:srgbClr val="FFFFFF"/>
                           </a:solidFill>
@@ -3733,15 +6871,15 @@
                   </a:tcPr>
                 </a:tc>
               </a:tr>
-              <a:tr h="594360">
-                <a:tc>
-                  <a:txBody>
-                    <a:bodyPr/>
-                    <a:lstStyle/>
-                    <a:p>
-                      <a:pPr algn="l"/>
-                      <a:r>
-                        <a:rPr lang="en-US" sz="1200" dirty="0">
+              <a:tr h="566928">
+                <a:tc>
+                  <a:txBody>
+                    <a:bodyPr/>
+                    <a:lstStyle/>
+                    <a:p>
+                      <a:pPr algn="l"/>
+                      <a:r>
+                        <a:rPr lang="en-US" sz="1150" dirty="0">
                           <a:solidFill>
                             <a:srgbClr val="1A1A1A"/>
                           </a:solidFill>
@@ -3764,7 +6902,7 @@
                     <a:p>
                       <a:pPr algn="l"/>
                       <a:r>
-                        <a:rPr lang="en-US" sz="1200" dirty="0">
+                        <a:rPr lang="en-US" sz="1150" dirty="0">
                           <a:solidFill>
                             <a:srgbClr val="1A1A1A"/>
                           </a:solidFill>
@@ -3787,7 +6925,7 @@
                     <a:p>
                       <a:pPr algn="l"/>
                       <a:r>
-                        <a:rPr lang="en-US" sz="1200" dirty="0">
+                        <a:rPr lang="en-US" sz="1150" dirty="0">
                           <a:solidFill>
                             <a:srgbClr val="1A1A1A"/>
                           </a:solidFill>
@@ -3810,7 +6948,7 @@
                     <a:p>
                       <a:pPr algn="l"/>
                       <a:r>
-                        <a:rPr lang="en-US" sz="1200" dirty="0">
+                        <a:rPr lang="en-US" sz="1150" dirty="0">
                           <a:solidFill>
                             <a:srgbClr val="1A1A1A"/>
                           </a:solidFill>
@@ -3827,15 +6965,15 @@
                   </a:tcPr>
                 </a:tc>
               </a:tr>
-              <a:tr h="594360">
-                <a:tc>
-                  <a:txBody>
-                    <a:bodyPr/>
-                    <a:lstStyle/>
-                    <a:p>
-                      <a:pPr algn="l"/>
-                      <a:r>
-                        <a:rPr lang="en-US" sz="1200" dirty="0">
+              <a:tr h="566928">
+                <a:tc>
+                  <a:txBody>
+                    <a:bodyPr/>
+                    <a:lstStyle/>
+                    <a:p>
+                      <a:pPr algn="l"/>
+                      <a:r>
+                        <a:rPr lang="en-US" sz="1150" dirty="0">
                           <a:solidFill>
                             <a:srgbClr val="1A1A1A"/>
                           </a:solidFill>
@@ -3858,7 +6996,7 @@
                     <a:p>
                       <a:pPr algn="l"/>
                       <a:r>
-                        <a:rPr lang="en-US" sz="1200" dirty="0">
+                        <a:rPr lang="en-US" sz="1150" dirty="0">
                           <a:solidFill>
                             <a:srgbClr val="1A1A1A"/>
                           </a:solidFill>
@@ -3881,7 +7019,7 @@
                     <a:p>
                       <a:pPr algn="l"/>
                       <a:r>
-                        <a:rPr lang="en-US" sz="1200" dirty="0">
+                        <a:rPr lang="en-US" sz="1150" dirty="0">
                           <a:solidFill>
                             <a:srgbClr val="1A1A1A"/>
                           </a:solidFill>
@@ -3904,7 +7042,7 @@
                     <a:p>
                       <a:pPr algn="l"/>
                       <a:r>
-                        <a:rPr lang="en-US" sz="1200" dirty="0">
+                        <a:rPr lang="en-US" sz="1150" dirty="0">
                           <a:solidFill>
                             <a:srgbClr val="1A1A1A"/>
                           </a:solidFill>
@@ -3921,15 +7059,15 @@
                   </a:tcPr>
                 </a:tc>
               </a:tr>
-              <a:tr h="594360">
-                <a:tc>
-                  <a:txBody>
-                    <a:bodyPr/>
-                    <a:lstStyle/>
-                    <a:p>
-                      <a:pPr algn="l"/>
-                      <a:r>
-                        <a:rPr lang="en-US" sz="1200" dirty="0">
+              <a:tr h="566928">
+                <a:tc>
+                  <a:txBody>
+                    <a:bodyPr/>
+                    <a:lstStyle/>
+                    <a:p>
+                      <a:pPr algn="l"/>
+                      <a:r>
+                        <a:rPr lang="en-US" sz="1150" dirty="0">
                           <a:solidFill>
                             <a:srgbClr val="1A1A1A"/>
                           </a:solidFill>
@@ -3952,7 +7090,7 @@
                     <a:p>
                       <a:pPr algn="l"/>
                       <a:r>
-                        <a:rPr lang="en-US" sz="1200" dirty="0">
+                        <a:rPr lang="en-US" sz="1150" dirty="0">
                           <a:solidFill>
                             <a:srgbClr val="1A1A1A"/>
                           </a:solidFill>
@@ -3975,7 +7113,7 @@
                     <a:p>
                       <a:pPr algn="l"/>
                       <a:r>
-                        <a:rPr lang="en-US" sz="1200" dirty="0">
+                        <a:rPr lang="en-US" sz="1150" dirty="0">
                           <a:solidFill>
                             <a:srgbClr val="1A1A1A"/>
                           </a:solidFill>
@@ -3998,7 +7136,7 @@
                     <a:p>
                       <a:pPr algn="l"/>
                       <a:r>
-                        <a:rPr lang="en-US" sz="1200" dirty="0">
+                        <a:rPr lang="en-US" sz="1150" dirty="0">
                           <a:solidFill>
                             <a:srgbClr val="1A1A1A"/>
                           </a:solidFill>
@@ -4015,15 +7153,15 @@
                   </a:tcPr>
                 </a:tc>
               </a:tr>
-              <a:tr h="594360">
-                <a:tc>
-                  <a:txBody>
-                    <a:bodyPr/>
-                    <a:lstStyle/>
-                    <a:p>
-                      <a:pPr algn="l"/>
-                      <a:r>
-                        <a:rPr lang="en-US" sz="1200" dirty="0">
+              <a:tr h="566928">
+                <a:tc>
+                  <a:txBody>
+                    <a:bodyPr/>
+                    <a:lstStyle/>
+                    <a:p>
+                      <a:pPr algn="l"/>
+                      <a:r>
+                        <a:rPr lang="en-US" sz="1150" dirty="0">
                           <a:solidFill>
                             <a:srgbClr val="1A1A1A"/>
                           </a:solidFill>
@@ -4046,7 +7184,7 @@
                     <a:p>
                       <a:pPr algn="l"/>
                       <a:r>
-                        <a:rPr lang="en-US" sz="1200" dirty="0">
+                        <a:rPr lang="en-US" sz="1150" dirty="0">
                           <a:solidFill>
                             <a:srgbClr val="1A1A1A"/>
                           </a:solidFill>
@@ -4069,7 +7207,7 @@
                     <a:p>
                       <a:pPr algn="l"/>
                       <a:r>
-                        <a:rPr lang="en-US" sz="1200" dirty="0">
+                        <a:rPr lang="en-US" sz="1150" dirty="0">
                           <a:solidFill>
                             <a:srgbClr val="1A1A1A"/>
                           </a:solidFill>
@@ -4092,7 +7230,7 @@
                     <a:p>
                       <a:pPr algn="l"/>
                       <a:r>
-                        <a:rPr lang="en-US" sz="1200" dirty="0">
+                        <a:rPr lang="en-US" sz="1150" dirty="0">
                           <a:solidFill>
                             <a:srgbClr val="1A1A1A"/>
                           </a:solidFill>
@@ -4109,15 +7247,15 @@
                   </a:tcPr>
                 </a:tc>
               </a:tr>
-              <a:tr h="594360">
-                <a:tc>
-                  <a:txBody>
-                    <a:bodyPr/>
-                    <a:lstStyle/>
-                    <a:p>
-                      <a:pPr algn="l"/>
-                      <a:r>
-                        <a:rPr lang="en-US" sz="1200" dirty="0">
+              <a:tr h="566928">
+                <a:tc>
+                  <a:txBody>
+                    <a:bodyPr/>
+                    <a:lstStyle/>
+                    <a:p>
+                      <a:pPr algn="l"/>
+                      <a:r>
+                        <a:rPr lang="en-US" sz="1150" dirty="0">
                           <a:solidFill>
                             <a:srgbClr val="1A1A1A"/>
                           </a:solidFill>
@@ -4140,7 +7278,7 @@
                     <a:p>
                       <a:pPr algn="l"/>
                       <a:r>
-                        <a:rPr lang="en-US" sz="1200" dirty="0">
+                        <a:rPr lang="en-US" sz="1150" dirty="0">
                           <a:solidFill>
                             <a:srgbClr val="1A1A1A"/>
                           </a:solidFill>
@@ -4163,7 +7301,7 @@
                     <a:p>
                       <a:pPr algn="l"/>
                       <a:r>
-                        <a:rPr lang="en-US" sz="1200" dirty="0">
+                        <a:rPr lang="en-US" sz="1150" dirty="0">
                           <a:solidFill>
                             <a:srgbClr val="1A1A1A"/>
                           </a:solidFill>
@@ -4186,7 +7324,101 @@
                     <a:p>
                       <a:pPr algn="l"/>
                       <a:r>
-                        <a:rPr lang="en-US" sz="1200" dirty="0">
+                        <a:rPr lang="en-US" sz="1150" dirty="0">
+                          <a:solidFill>
+                            <a:srgbClr val="1A1A1A"/>
+                          </a:solidFill>
+                          <a:latin typeface="Calibri"/>
+                        </a:rPr>
+                        <a:t>Medium</a:t>
+                      </a:r>
+                    </a:p>
+                  </a:txBody>
+                  <a:tcPr marL="45720" marR="45720" marT="22860" marB="22860" anchor="ctr">
+                    <a:solidFill>
+                      <a:srgbClr val="FFFFFF"/>
+                    </a:solidFill>
+                  </a:tcPr>
+                </a:tc>
+              </a:tr>
+              <a:tr h="566928">
+                <a:tc>
+                  <a:txBody>
+                    <a:bodyPr/>
+                    <a:lstStyle/>
+                    <a:p>
+                      <a:pPr algn="l"/>
+                      <a:r>
+                        <a:rPr lang="en-US" sz="1150" dirty="0">
+                          <a:solidFill>
+                            <a:srgbClr val="1A1A1A"/>
+                          </a:solidFill>
+                          <a:latin typeface="Calibri"/>
+                        </a:rPr>
+                        <a:t>Close UP/Maharashtra distribution white space (both categories)</a:t>
+                      </a:r>
+                    </a:p>
+                  </a:txBody>
+                  <a:tcPr marL="45720" marR="45720" marT="22860" marB="22860" anchor="ctr">
+                    <a:solidFill>
+                      <a:srgbClr val="FFFFFF"/>
+                    </a:solidFill>
+                  </a:tcPr>
+                </a:tc>
+                <a:tc>
+                  <a:txBody>
+                    <a:bodyPr/>
+                    <a:lstStyle/>
+                    <a:p>
+                      <a:pPr algn="l"/>
+                      <a:r>
+                        <a:rPr lang="en-US" sz="1150" dirty="0">
+                          <a:solidFill>
+                            <a:srgbClr val="1A1A1A"/>
+                          </a:solidFill>
+                          <a:latin typeface="Calibri"/>
+                        </a:rPr>
+                        <a:t>RKAM / Zone Sales</a:t>
+                      </a:r>
+                    </a:p>
+                  </a:txBody>
+                  <a:tcPr marL="45720" marR="45720" marT="22860" marB="22860" anchor="ctr">
+                    <a:solidFill>
+                      <a:srgbClr val="FFFFFF"/>
+                    </a:solidFill>
+                  </a:tcPr>
+                </a:tc>
+                <a:tc>
+                  <a:txBody>
+                    <a:bodyPr/>
+                    <a:lstStyle/>
+                    <a:p>
+                      <a:pPr algn="l"/>
+                      <a:r>
+                        <a:rPr lang="en-US" sz="1150" dirty="0">
+                          <a:solidFill>
+                            <a:srgbClr val="1A1A1A"/>
+                          </a:solidFill>
+                          <a:latin typeface="Calibri"/>
+                        </a:rPr>
+                        <a:t>Q3 FY27</a:t>
+                      </a:r>
+                    </a:p>
+                  </a:txBody>
+                  <a:tcPr marL="45720" marR="45720" marT="22860" marB="22860" anchor="ctr">
+                    <a:solidFill>
+                      <a:srgbClr val="FFFFFF"/>
+                    </a:solidFill>
+                  </a:tcPr>
+                </a:tc>
+                <a:tc>
+                  <a:txBody>
+                    <a:bodyPr/>
+                    <a:lstStyle/>
+                    <a:p>
+                      <a:pPr algn="l"/>
+                      <a:r>
+                        <a:rPr lang="en-US" sz="1150" dirty="0">
                           <a:solidFill>
                             <a:srgbClr val="1A1A1A"/>
                           </a:solidFill>

</xml_diff>